<commit_message>
docs: remove explicit client name from architecture deck
- Replace all "Kohler" references with generic, industry-appropriate wording
  (kitchen & bath / distributor context retained so it still reads as
  purpose-built) so the client name is not mentioned in the document

Co-authored-by: Cursor <cursoragent@cursor.com>
</commit_message>
<xml_diff>
--- a/demo/PO-Fulfillment-Orchestration-Architecture.pptx
+++ b/demo/PO-Fulfillment-Orchestration-Architecture.pptx
@@ -3280,7 +3280,7 @@
                 </a:solidFill>
                 <a:latin typeface="Segoe UI"/>
               </a:rPr>
-              <a:t>ORDER ASSISTANT AI  ·  FOR KOHLER ORDER FULFILLMENT</a:t>
+              <a:t>ORDER ASSISTANT AI  ·  FOR KITCHEN &amp; BATH ORDER FULFILLMENT</a:t>
             </a:r>
           </a:p>
         </p:txBody>
@@ -3436,7 +3436,7 @@
                 </a:solidFill>
                 <a:latin typeface="Segoe UI"/>
               </a:rPr>
-              <a:t>An Order Assistant AI that turns every distributor purchase order Kohler receives — </a:t>
+              <a:t>An Order Assistant AI that turns every distributor purchase order the business receives — </a:t>
             </a:r>
           </a:p>
           <a:p>
@@ -3855,7 +3855,7 @@
                 </a:solidFill>
                 <a:latin typeface="Segoe UI"/>
               </a:rPr>
-              <a:t>Order Assistant AI  ·  PO-to-Fulfillment Orchestration  ·  Kohler</a:t>
+              <a:t>Order Assistant AI  ·  PO-to-Fulfillment Orchestration</a:t>
             </a:r>
           </a:p>
         </p:txBody>
@@ -6219,7 +6219,7 @@
                 </a:solidFill>
                 <a:latin typeface="Segoe UI"/>
               </a:rPr>
-              <a:t>Order Assistant AI  ·  PO-to-Fulfillment Orchestration  ·  Kohler</a:t>
+              <a:t>Order Assistant AI  ·  PO-to-Fulfillment Orchestration</a:t>
             </a:r>
           </a:p>
         </p:txBody>
@@ -8574,7 +8574,7 @@
                 </a:solidFill>
                 <a:latin typeface="Segoe UI"/>
               </a:rPr>
-              <a:t>Order Assistant AI  ·  PO-to-Fulfillment Orchestration  ·  Kohler</a:t>
+              <a:t>Order Assistant AI  ·  PO-to-Fulfillment Orchestration</a:t>
             </a:r>
           </a:p>
         </p:txBody>
@@ -10749,7 +10749,7 @@
                 </a:solidFill>
                 <a:latin typeface="Segoe UI"/>
               </a:rPr>
-              <a:t>Order Assistant AI  ·  PO-to-Fulfillment Orchestration  ·  Kohler</a:t>
+              <a:t>Order Assistant AI  ·  PO-to-Fulfillment Orchestration</a:t>
             </a:r>
           </a:p>
         </p:txBody>
@@ -12863,7 +12863,7 @@
                 </a:solidFill>
                 <a:latin typeface="Segoe UI"/>
               </a:rPr>
-              <a:t>Order Assistant AI  ·  PO-to-Fulfillment Orchestration  ·  Kohler</a:t>
+              <a:t>Order Assistant AI  ·  PO-to-Fulfillment Orchestration</a:t>
             </a:r>
           </a:p>
         </p:txBody>
@@ -14567,7 +14567,7 @@
                 </a:solidFill>
                 <a:latin typeface="Segoe UI"/>
               </a:rPr>
-              <a:t>Order Assistant AI  ·  PO-to-Fulfillment Orchestration  ·  Kohler</a:t>
+              <a:t>Order Assistant AI  ·  PO-to-Fulfillment Orchestration</a:t>
             </a:r>
           </a:p>
         </p:txBody>
@@ -16874,7 +16874,7 @@
                 </a:solidFill>
                 <a:latin typeface="Segoe UI"/>
               </a:rPr>
-              <a:t>Order Assistant AI  ·  PO-to-Fulfillment Orchestration  ·  Kohler</a:t>
+              <a:t>Order Assistant AI  ·  PO-to-Fulfillment Orchestration</a:t>
             </a:r>
           </a:p>
         </p:txBody>
@@ -18957,7 +18957,7 @@
                 </a:solidFill>
                 <a:latin typeface="Segoe UI"/>
               </a:rPr>
-              <a:t>Order Assistant AI  ·  PO-to-Fulfillment Orchestration  ·  Kohler</a:t>
+              <a:t>Order Assistant AI  ·  PO-to-Fulfillment Orchestration</a:t>
             </a:r>
           </a:p>
         </p:txBody>
@@ -20460,7 +20460,7 @@
                 </a:solidFill>
                 <a:latin typeface="Segoe UI"/>
               </a:rPr>
-              <a:t>Order Assistant AI  ·  PO-to-Fulfillment Orchestration  ·  Kohler</a:t>
+              <a:t>Order Assistant AI  ·  PO-to-Fulfillment Orchestration</a:t>
             </a:r>
           </a:p>
         </p:txBody>
@@ -21865,7 +21865,7 @@
                 </a:solidFill>
                 <a:latin typeface="Segoe UI"/>
               </a:rPr>
-              <a:t>The business need and problem, the solution approach, and the impact for Kohler.</a:t>
+              <a:t>The business need and problem, the solution approach, and the business impact.</a:t>
             </a:r>
           </a:p>
         </p:txBody>
@@ -22195,7 +22195,7 @@
                 </a:solidFill>
                 <a:latin typeface="Segoe UI"/>
               </a:rPr>
-              <a:t>Order Assistant AI  ·  PO-to-Fulfillment Orchestration  ·  Kohler</a:t>
+              <a:t>Order Assistant AI  ·  PO-to-Fulfillment Orchestration</a:t>
             </a:r>
           </a:p>
         </p:txBody>
@@ -24286,7 +24286,7 @@
                 </a:solidFill>
                 <a:latin typeface="Segoe UI"/>
               </a:rPr>
-              <a:t>Next: connect live systems, add LLM-assisted reasoning, and pilot with real Kohler POs.</a:t>
+              <a:t>Next: connect live systems, add LLM-assisted reasoning, and pilot with real production POs.</a:t>
             </a:r>
           </a:p>
         </p:txBody>
@@ -24437,7 +24437,7 @@
                 </a:solidFill>
                 <a:latin typeface="Segoe UI"/>
               </a:rPr>
-              <a:t>BUSINESS NEED &amp; PROBLEM  ·  KOHLER</a:t>
+              <a:t>BUSINESS NEED &amp; PROBLEM</a:t>
             </a:r>
           </a:p>
         </p:txBody>
@@ -24616,7 +24616,7 @@
                 </a:solidFill>
                 <a:latin typeface="Segoe UI"/>
               </a:rPr>
-              <a:t>Order Assistant AI  ·  PO-to-Fulfillment Orchestration  ·  Kohler</a:t>
+              <a:t>Order Assistant AI  ·  PO-to-Fulfillment Orchestration</a:t>
             </a:r>
           </a:p>
         </p:txBody>
@@ -24751,7 +24751,7 @@
                 </a:solidFill>
                 <a:latin typeface="Segoe UI"/>
               </a:rPr>
-              <a:t>Kohler receives a high volume of purchase orders from wholesale distributors, showrooms and retailers </a:t>
+              <a:t>The business receives a high volume of purchase orders from wholesale distributors, showrooms and retailers </a:t>
             </a:r>
           </a:p>
           <a:p>
@@ -24953,7 +24953,7 @@
                 </a:solidFill>
                 <a:latin typeface="Segoe UI"/>
               </a:rPr>
-              <a:t>Kohler continually supersedes fixtures, cartridges and finishes. CSRs must catch obsolete SKUs and find the approved replacement on every order.</a:t>
+              <a:t>The catalog continually supersedes fixtures, cartridges and finishes. CSRs must catch obsolete SKUs and find the approved replacement on every order.</a:t>
             </a:r>
           </a:p>
         </p:txBody>
@@ -25925,7 +25925,7 @@
                 </a:solidFill>
                 <a:latin typeface="Segoe UI"/>
               </a:rPr>
-              <a:t>Order Assistant AI  ·  PO-to-Fulfillment Orchestration  ·  Kohler</a:t>
+              <a:t>Order Assistant AI  ·  PO-to-Fulfillment Orchestration</a:t>
             </a:r>
           </a:p>
         </p:txBody>
@@ -27081,7 +27081,7 @@
                 </a:solidFill>
                 <a:latin typeface="Segoe UI"/>
               </a:rPr>
-              <a:t>BUSINESS IMPACT  ·  KOHLER</a:t>
+              <a:t>BUSINESS IMPACT</a:t>
             </a:r>
           </a:p>
         </p:txBody>
@@ -27260,7 +27260,7 @@
                 </a:solidFill>
                 <a:latin typeface="Segoe UI"/>
               </a:rPr>
-              <a:t>Order Assistant AI  ·  PO-to-Fulfillment Orchestration  ·  Kohler</a:t>
+              <a:t>Order Assistant AI  ·  PO-to-Fulfillment Orchestration</a:t>
             </a:r>
           </a:p>
         </p:txBody>
@@ -28465,7 +28465,7 @@
                 </a:solidFill>
                 <a:latin typeface="Segoe UI"/>
               </a:rPr>
-              <a:t>Business outcomes for Kohler</a:t>
+              <a:t>Business outcomes</a:t>
             </a:r>
           </a:p>
         </p:txBody>
@@ -29699,7 +29699,7 @@
                 </a:solidFill>
                 <a:latin typeface="Segoe UI"/>
               </a:rPr>
-              <a:t>Order Assistant AI  ·  PO-to-Fulfillment Orchestration  ·  Kohler</a:t>
+              <a:t>Order Assistant AI  ·  PO-to-Fulfillment Orchestration</a:t>
             </a:r>
           </a:p>
         </p:txBody>
@@ -33703,7 +33703,7 @@
                 </a:solidFill>
                 <a:latin typeface="Segoe UI"/>
               </a:rPr>
-              <a:t>Order Assistant AI  ·  PO-to-Fulfillment Orchestration  ·  Kohler</a:t>
+              <a:t>Order Assistant AI  ·  PO-to-Fulfillment Orchestration</a:t>
             </a:r>
           </a:p>
         </p:txBody>
@@ -36171,7 +36171,7 @@
                 </a:solidFill>
                 <a:latin typeface="Segoe UI"/>
               </a:rPr>
-              <a:t>Order Assistant AI  ·  PO-to-Fulfillment Orchestration  ·  Kohler</a:t>
+              <a:t>Order Assistant AI  ·  PO-to-Fulfillment Orchestration</a:t>
             </a:r>
           </a:p>
         </p:txBody>

</xml_diff>

<commit_message>
docs: remove large background section numbers from divider slides
Co-authored-by: Cursor <cursoragent@cursor.com>
</commit_message>
<xml_diff>
--- a/demo/PO-Fulfillment-Orchestration-Architecture.pptx
+++ b/demo/PO-Fulfillment-Orchestration-Architecture.pptx
@@ -5678,8 +5678,8 @@
         </p:nvSpPr>
         <p:spPr>
           <a:xfrm>
-            <a:off x="1005840" y="2148840"/>
-            <a:ext cx="3657600" cy="1371600"/>
+            <a:off x="1051560" y="2651760"/>
+            <a:ext cx="10058400" cy="457200"/>
           </a:xfrm>
           <a:prstGeom prst="rect">
             <a:avLst/>
@@ -5704,13 +5704,13 @@
               </a:spcAft>
             </a:pPr>
             <a:r>
-              <a:rPr sz="9600" b="1" i="0">
-                <a:solidFill>
-                  <a:srgbClr val="2E2E40"/>
-                </a:solidFill>
-                <a:latin typeface="Segoe UI"/>
-              </a:rPr>
-              <a:t>03</a:t>
+              <a:rPr sz="1300" b="1" i="0">
+                <a:solidFill>
+                  <a:srgbClr val="FFE600"/>
+                </a:solidFill>
+                <a:latin typeface="Segoe UI"/>
+              </a:rPr>
+              <a:t>SECTION THE AI TOOL WE BUILT</a:t>
             </a:r>
           </a:p>
         </p:txBody>
@@ -5723,8 +5723,8 @@
         </p:nvSpPr>
         <p:spPr>
           <a:xfrm>
-            <a:off x="1051560" y="2651760"/>
-            <a:ext cx="10058400" cy="457200"/>
+            <a:off x="1051560" y="3017520"/>
+            <a:ext cx="10058400" cy="914400"/>
           </a:xfrm>
           <a:prstGeom prst="rect">
             <a:avLst/>
@@ -5749,51 +5749,6 @@
               </a:spcAft>
             </a:pPr>
             <a:r>
-              <a:rPr sz="1300" b="1" i="0">
-                <a:solidFill>
-                  <a:srgbClr val="FFE600"/>
-                </a:solidFill>
-                <a:latin typeface="Segoe UI"/>
-              </a:rPr>
-              <a:t>SECTION THE AI TOOL WE BUILT</a:t>
-            </a:r>
-          </a:p>
-        </p:txBody>
-      </p:sp>
-      <p:sp>
-        <p:nvSpPr>
-          <p:cNvPr id="7" name="TextBox 6"/>
-          <p:cNvSpPr txBox="1"/>
-          <p:nvPr/>
-        </p:nvSpPr>
-        <p:spPr>
-          <a:xfrm>
-            <a:off x="1051560" y="3017520"/>
-            <a:ext cx="10058400" cy="914400"/>
-          </a:xfrm>
-          <a:prstGeom prst="rect">
-            <a:avLst/>
-          </a:prstGeom>
-          <a:noFill/>
-        </p:spPr>
-        <p:txBody>
-          <a:bodyPr wrap="square" anchor="t" lIns="0" rIns="0" tIns="0" bIns="0">
-            <a:spAutoFit/>
-          </a:bodyPr>
-          <a:lstStyle/>
-          <a:p>
-            <a:pPr algn="l">
-              <a:lnSpc>
-                <a:spcPct val="100000"/>
-              </a:lnSpc>
-              <a:spcBef>
-                <a:spcPts val="0"/>
-              </a:spcBef>
-              <a:spcAft>
-                <a:spcPts val="200"/>
-              </a:spcAft>
-            </a:pPr>
-            <a:r>
               <a:rPr sz="3800" b="1" i="0">
                 <a:solidFill>
                   <a:srgbClr val="FFFFFF"/>
@@ -5807,7 +5762,7 @@
       </p:sp>
       <p:sp>
         <p:nvSpPr>
-          <p:cNvPr id="8" name="Rectangle 7"/>
+          <p:cNvPr id="7" name="Rectangle 6"/>
           <p:cNvSpPr/>
           <p:nvPr/>
         </p:nvSpPr>
@@ -5851,7 +5806,7 @@
       </p:sp>
       <p:sp>
         <p:nvSpPr>
-          <p:cNvPr id="9" name="TextBox 8"/>
+          <p:cNvPr id="8" name="TextBox 7"/>
           <p:cNvSpPr txBox="1"/>
           <p:nvPr/>
         </p:nvSpPr>
@@ -21654,8 +21609,8 @@
         </p:nvSpPr>
         <p:spPr>
           <a:xfrm>
-            <a:off x="1005840" y="2148840"/>
-            <a:ext cx="3657600" cy="1371600"/>
+            <a:off x="1051560" y="2651760"/>
+            <a:ext cx="10058400" cy="457200"/>
           </a:xfrm>
           <a:prstGeom prst="rect">
             <a:avLst/>
@@ -21680,13 +21635,13 @@
               </a:spcAft>
             </a:pPr>
             <a:r>
-              <a:rPr sz="9600" b="1" i="0">
-                <a:solidFill>
-                  <a:srgbClr val="2E2E40"/>
-                </a:solidFill>
-                <a:latin typeface="Segoe UI"/>
-              </a:rPr>
-              <a:t>01</a:t>
+              <a:rPr sz="1300" b="1" i="0">
+                <a:solidFill>
+                  <a:srgbClr val="FFE600"/>
+                </a:solidFill>
+                <a:latin typeface="Segoe UI"/>
+              </a:rPr>
+              <a:t>SECTION BUSINESS CONTEXT</a:t>
             </a:r>
           </a:p>
         </p:txBody>
@@ -21699,8 +21654,8 @@
         </p:nvSpPr>
         <p:spPr>
           <a:xfrm>
-            <a:off x="1051560" y="2651760"/>
-            <a:ext cx="10058400" cy="457200"/>
+            <a:off x="1051560" y="3017520"/>
+            <a:ext cx="10058400" cy="914400"/>
           </a:xfrm>
           <a:prstGeom prst="rect">
             <a:avLst/>
@@ -21725,51 +21680,6 @@
               </a:spcAft>
             </a:pPr>
             <a:r>
-              <a:rPr sz="1300" b="1" i="0">
-                <a:solidFill>
-                  <a:srgbClr val="FFE600"/>
-                </a:solidFill>
-                <a:latin typeface="Segoe UI"/>
-              </a:rPr>
-              <a:t>SECTION BUSINESS CONTEXT</a:t>
-            </a:r>
-          </a:p>
-        </p:txBody>
-      </p:sp>
-      <p:sp>
-        <p:nvSpPr>
-          <p:cNvPr id="7" name="TextBox 6"/>
-          <p:cNvSpPr txBox="1"/>
-          <p:nvPr/>
-        </p:nvSpPr>
-        <p:spPr>
-          <a:xfrm>
-            <a:off x="1051560" y="3017520"/>
-            <a:ext cx="10058400" cy="914400"/>
-          </a:xfrm>
-          <a:prstGeom prst="rect">
-            <a:avLst/>
-          </a:prstGeom>
-          <a:noFill/>
-        </p:spPr>
-        <p:txBody>
-          <a:bodyPr wrap="square" anchor="t" lIns="0" rIns="0" tIns="0" bIns="0">
-            <a:spAutoFit/>
-          </a:bodyPr>
-          <a:lstStyle/>
-          <a:p>
-            <a:pPr algn="l">
-              <a:lnSpc>
-                <a:spcPct val="100000"/>
-              </a:lnSpc>
-              <a:spcBef>
-                <a:spcPts val="0"/>
-              </a:spcBef>
-              <a:spcAft>
-                <a:spcPts val="200"/>
-              </a:spcAft>
-            </a:pPr>
-            <a:r>
               <a:rPr sz="3800" b="1" i="0">
                 <a:solidFill>
                   <a:srgbClr val="FFFFFF"/>
@@ -21783,7 +21693,7 @@
       </p:sp>
       <p:sp>
         <p:nvSpPr>
-          <p:cNvPr id="8" name="Rectangle 7"/>
+          <p:cNvPr id="7" name="Rectangle 6"/>
           <p:cNvSpPr/>
           <p:nvPr/>
         </p:nvSpPr>
@@ -21827,7 +21737,7 @@
       </p:sp>
       <p:sp>
         <p:nvSpPr>
-          <p:cNvPr id="9" name="TextBox 8"/>
+          <p:cNvPr id="8" name="TextBox 7"/>
           <p:cNvSpPr txBox="1"/>
           <p:nvPr/>
         </p:nvSpPr>
@@ -29158,8 +29068,8 @@
         </p:nvSpPr>
         <p:spPr>
           <a:xfrm>
-            <a:off x="1005840" y="2148840"/>
-            <a:ext cx="3657600" cy="1371600"/>
+            <a:off x="1051560" y="2651760"/>
+            <a:ext cx="10058400" cy="457200"/>
           </a:xfrm>
           <a:prstGeom prst="rect">
             <a:avLst/>
@@ -29184,13 +29094,13 @@
               </a:spcAft>
             </a:pPr>
             <a:r>
-              <a:rPr sz="9600" b="1" i="0">
-                <a:solidFill>
-                  <a:srgbClr val="2E2E40"/>
-                </a:solidFill>
-                <a:latin typeface="Segoe UI"/>
-              </a:rPr>
-              <a:t>02</a:t>
+              <a:rPr sz="1300" b="1" i="0">
+                <a:solidFill>
+                  <a:srgbClr val="FFE600"/>
+                </a:solidFill>
+                <a:latin typeface="Segoe UI"/>
+              </a:rPr>
+              <a:t>SECTION SOLUTION ARCHITECTURE &amp; DESIGN</a:t>
             </a:r>
           </a:p>
         </p:txBody>
@@ -29203,8 +29113,8 @@
         </p:nvSpPr>
         <p:spPr>
           <a:xfrm>
-            <a:off x="1051560" y="2651760"/>
-            <a:ext cx="10058400" cy="457200"/>
+            <a:off x="1051560" y="3017520"/>
+            <a:ext cx="10058400" cy="914400"/>
           </a:xfrm>
           <a:prstGeom prst="rect">
             <a:avLst/>
@@ -29229,51 +29139,6 @@
               </a:spcAft>
             </a:pPr>
             <a:r>
-              <a:rPr sz="1300" b="1" i="0">
-                <a:solidFill>
-                  <a:srgbClr val="FFE600"/>
-                </a:solidFill>
-                <a:latin typeface="Segoe UI"/>
-              </a:rPr>
-              <a:t>SECTION SOLUTION ARCHITECTURE &amp; DESIGN</a:t>
-            </a:r>
-          </a:p>
-        </p:txBody>
-      </p:sp>
-      <p:sp>
-        <p:nvSpPr>
-          <p:cNvPr id="7" name="TextBox 6"/>
-          <p:cNvSpPr txBox="1"/>
-          <p:nvPr/>
-        </p:nvSpPr>
-        <p:spPr>
-          <a:xfrm>
-            <a:off x="1051560" y="3017520"/>
-            <a:ext cx="10058400" cy="914400"/>
-          </a:xfrm>
-          <a:prstGeom prst="rect">
-            <a:avLst/>
-          </a:prstGeom>
-          <a:noFill/>
-        </p:spPr>
-        <p:txBody>
-          <a:bodyPr wrap="square" anchor="t" lIns="0" rIns="0" tIns="0" bIns="0">
-            <a:spAutoFit/>
-          </a:bodyPr>
-          <a:lstStyle/>
-          <a:p>
-            <a:pPr algn="l">
-              <a:lnSpc>
-                <a:spcPct val="100000"/>
-              </a:lnSpc>
-              <a:spcBef>
-                <a:spcPts val="0"/>
-              </a:spcBef>
-              <a:spcAft>
-                <a:spcPts val="200"/>
-              </a:spcAft>
-            </a:pPr>
-            <a:r>
               <a:rPr sz="3800" b="1" i="0">
                 <a:solidFill>
                   <a:srgbClr val="FFFFFF"/>
@@ -29287,7 +29152,7 @@
       </p:sp>
       <p:sp>
         <p:nvSpPr>
-          <p:cNvPr id="8" name="Rectangle 7"/>
+          <p:cNvPr id="7" name="Rectangle 6"/>
           <p:cNvSpPr/>
           <p:nvPr/>
         </p:nvSpPr>
@@ -29331,7 +29196,7 @@
       </p:sp>
       <p:sp>
         <p:nvSpPr>
-          <p:cNvPr id="9" name="TextBox 8"/>
+          <p:cNvPr id="8" name="TextBox 7"/>
           <p:cNvSpPr txBox="1"/>
           <p:nvPr/>
         </p:nvSpPr>

</xml_diff>

<commit_message>
docs: genericize deck copy (remove product/industry terms and "distributor")
- Title: "for kitchen & bath" -> "for purchase-order fulfillment"
- Rewrite opening subtitle into a cleaner, product-neutral sentence
- Remove all "distributor" wording and product/brand terms (Clearflo,
  plumbing, fixtures/cartridges/finishes) from business copy and the
  Happy Flow example so the deck stays client- and product-neutral

Co-authored-by: Cursor <cursoragent@cursor.com>
</commit_message>
<xml_diff>
--- a/demo/PO-Fulfillment-Orchestration-Architecture.pptx
+++ b/demo/PO-Fulfillment-Orchestration-Architecture.pptx
@@ -3280,7 +3280,7 @@
                 </a:solidFill>
                 <a:latin typeface="Segoe UI"/>
               </a:rPr>
-              <a:t>ORDER ASSISTANT AI  ·  FOR KITCHEN &amp; BATH ORDER FULFILLMENT</a:t>
+              <a:t>ORDER ASSISTANT AI  ·  FOR PURCHASE-ORDER FULFILLMENT</a:t>
             </a:r>
           </a:p>
         </p:txBody>
@@ -3436,7 +3436,7 @@
                 </a:solidFill>
                 <a:latin typeface="Segoe UI"/>
               </a:rPr>
-              <a:t>An Order Assistant AI that turns every distributor purchase order the business receives — </a:t>
+              <a:t>An intelligent Order Assistant AI that transforms every incoming purchase order — from </a:t>
             </a:r>
           </a:p>
           <a:p>
@@ -3458,7 +3458,7 @@
                 </a:solidFill>
                 <a:latin typeface="Segoe UI"/>
               </a:rPr>
-              <a:t>from intake to shipment — into a fast, accurate, self-validating workflow, with a </a:t>
+              <a:t>intake through to shipment — into a fast, accurate and self-validating workflow, powered by a </a:t>
             </a:r>
           </a:p>
           <a:p>
@@ -3480,7 +3480,7 @@
                 </a:solidFill>
                 <a:latin typeface="Segoe UI"/>
               </a:rPr>
-              <a:t>team of specialised AI agents and human-in-the-loop control on exceptions.</a:t>
+              <a:t>team of specialised AI agents, with human judgement applied only where it truly matters.</a:t>
             </a:r>
           </a:p>
         </p:txBody>
@@ -15850,7 +15850,7 @@
                 </a:solidFill>
                 <a:latin typeface="Segoe UI"/>
               </a:rPr>
-              <a:t>Great Lakes Plumbing Supply Co  ·  john.miller@glps.com</a:t>
+              <a:t>Great Lakes Supply Co  ·  john.miller@glps.com</a:t>
             </a:r>
           </a:p>
           <a:p>
@@ -15916,7 +15916,7 @@
                 </a:solidFill>
                 <a:latin typeface="Segoe UI"/>
               </a:rPr>
-              <a:t>1  SKU-CTG-4520  Ceramic Disc Cartridge     100 EA</a:t>
+              <a:t>1  SKU-CTG-4520  Catalog item A     100 EA</a:t>
             </a:r>
           </a:p>
           <a:p>
@@ -15938,7 +15938,7 @@
                 </a:solidFill>
                 <a:latin typeface="Segoe UI"/>
               </a:rPr>
-              <a:t>2  SKU-SEL-1150  Tank-to-Bowl Gasket Kit    120 EA</a:t>
+              <a:t>2  SKU-SEL-1150  Catalog item B     120 EA</a:t>
             </a:r>
           </a:p>
           <a:p>
@@ -15960,7 +15960,7 @@
                 </a:solidFill>
                 <a:latin typeface="Segoe UI"/>
               </a:rPr>
-              <a:t>3  SKU-VLV-2201  Pressure-Balancing Valve    15 EA</a:t>
+              <a:t>3  SKU-VLV-2201  Catalog item C      15 EA</a:t>
             </a:r>
           </a:p>
         </p:txBody>
@@ -24392,7 +24392,7 @@
                 </a:solidFill>
                 <a:latin typeface="Segoe UI"/>
               </a:rPr>
-              <a:t>From distributor PO to shipment — the manual bottleneck</a:t>
+              <a:t>From purchase order to shipment — the manual bottleneck</a:t>
             </a:r>
           </a:p>
         </p:txBody>
@@ -24661,7 +24661,7 @@
                 </a:solidFill>
                 <a:latin typeface="Segoe UI"/>
               </a:rPr>
-              <a:t>The business receives a high volume of purchase orders from wholesale distributors, showrooms and retailers </a:t>
+              <a:t>The business receives a high volume of purchase orders from its customers across </a:t>
             </a:r>
           </a:p>
           <a:p>
@@ -24683,7 +24683,7 @@
                 </a:solidFill>
                 <a:latin typeface="Segoe UI"/>
               </a:rPr>
-              <a:t>(e.g. Great Lakes Plumbing) across email, EDI and portals. Every order must be validated, priced, sourced and approved before it can ship — today that work lands on customer-service reps, order by order, line by line.</a:t>
+              <a:t>email, EDI and portals. Every order must be validated, priced, sourced and approved before it can ship — today that work lands on customer-service reps, order by order, line by line.</a:t>
             </a:r>
           </a:p>
         </p:txBody>
@@ -24863,7 +24863,7 @@
                 </a:solidFill>
                 <a:latin typeface="Segoe UI"/>
               </a:rPr>
-              <a:t>The catalog continually supersedes fixtures, cartridges and finishes. CSRs must catch obsolete SKUs and find the approved replacement on every order.</a:t>
+              <a:t>The catalog is continually refreshed and older SKUs are superseded. CSRs must catch obsolete items and find the approved replacement on every order.</a:t>
             </a:r>
           </a:p>
         </p:txBody>
@@ -25043,7 +25043,7 @@
                 </a:solidFill>
                 <a:latin typeface="Segoe UI"/>
               </a:rPr>
-              <a:t>Items sell in each, kits and cases (e.g. Clearflo drain kits). Ordered quantities must be converted correctly or shipments and invoices go wrong.</a:t>
+              <a:t>Items sell in different units — each, kits and cases. Ordered quantities must be converted correctly or shipments and invoices go wrong.</a:t>
             </a:r>
           </a:p>
         </p:txBody>
@@ -25223,7 +25223,7 @@
                 </a:solidFill>
                 <a:latin typeface="Segoe UI"/>
               </a:rPr>
-              <a:t>Distributor-specific contract pricing, promos and rebates — plus family-level discount / margin policies that must not be breached.</a:t>
+              <a:t>Customer-specific contract pricing, promos and rebates — plus family-level discount / margin policies that must not be breached.</a:t>
             </a:r>
           </a:p>
         </p:txBody>
@@ -25403,7 +25403,7 @@
                 </a:solidFill>
                 <a:latin typeface="Segoe UI"/>
               </a:rPr>
-              <a:t>Validating the distributor account, the ordering buyer, credit limits and spend approvals — by hand, across multiple systems.</a:t>
+              <a:t>Validating the customer account, the ordering buyer, credit limits and spend approvals — by hand, across multiple systems.</a:t>
             </a:r>
           </a:p>
         </p:txBody>
@@ -28437,7 +28437,7 @@
                 </a:solidFill>
                 <a:latin typeface="Segoe UI"/>
               </a:rPr>
-              <a:t>Faster distributor turnaround</a:t>
+              <a:t>Faster order turnaround</a:t>
             </a:r>
           </a:p>
         </p:txBody>

</xml_diff>

<commit_message>
docs: product-neutral deck (drop tech names + POC framing, 4 intake channels, richer flowchart)
- Remove all technology mentions (Python, Streamlit, Excel workbooks)
- Reframe deck as a finished platform: drop "POC/today vs production"
  framing, rename tech slide to "Platform & enterprise readiness",
  rename demo slides to "Scenario 1/2", update closing copy
- Model the 4 business intake channels everywhere (Email PO, PDF PO,
  Excel PO, Scanned PO) and rename the tier to "Customer Interaction"
- Rebuild the process flowchart into an elaborate end-to-end view with
  intake channels, validation/pricing/credit stages, and a
  human-in-the-loop CSR lane (resolve / approve / reject routing)

Co-authored-by: Cursor <cursoragent@cursor.com>
</commit_message>
<xml_diff>
--- a/demo/PO-Fulfillment-Orchestration-Architecture.pptx
+++ b/demo/PO-Fulfillment-Orchestration-Architecture.pptx
@@ -8574,7 +8574,7 @@
                 </a:solidFill>
                 <a:latin typeface="Segoe UI"/>
               </a:rPr>
-              <a:t>Each agent reads governed master data (mock Excel workbooks in the POC; enterprise systems in production). Change the data, not the code, to change behaviour.</a:t>
+              <a:t>Each agent reads governed master data sourced from the enterprise systems of record. Change the data, not the code, to change behaviour.</a:t>
             </a:r>
           </a:p>
         </p:txBody>
@@ -14343,7 +14343,7 @@
                 </a:solidFill>
                 <a:latin typeface="Segoe UI"/>
               </a:rPr>
-              <a:t>DEMO 1</a:t>
+              <a:t>SCENARIO 1</a:t>
             </a:r>
           </a:p>
         </p:txBody>
@@ -16650,7 +16650,7 @@
                 </a:solidFill>
                 <a:latin typeface="Segoe UI"/>
               </a:rPr>
-              <a:t>DEMO 2</a:t>
+              <a:t>SCENARIO 2</a:t>
             </a:r>
           </a:p>
         </p:txBody>
@@ -21971,7 +21971,7 @@
                 </a:solidFill>
                 <a:latin typeface="Segoe UI"/>
               </a:rPr>
-              <a:t>Technology &amp; deployment</a:t>
+              <a:t>Platform &amp; enterprise readiness</a:t>
             </a:r>
           </a:p>
         </p:txBody>
@@ -22240,7 +22240,7 @@
                 </a:solidFill>
                 <a:latin typeface="Segoe UI"/>
               </a:rPr>
-              <a:t>POC (today)</a:t>
+              <a:t>Solution components</a:t>
             </a:r>
           </a:p>
         </p:txBody>
@@ -22329,7 +22329,7 @@
                 </a:solidFill>
                 <a:latin typeface="Segoe UI"/>
               </a:rPr>
-              <a:t>Python orchestration engine</a:t>
+              <a:t>Agent orchestration engine</a:t>
             </a:r>
           </a:p>
         </p:txBody>
@@ -22418,7 +22418,7 @@
                 </a:solidFill>
                 <a:latin typeface="Segoe UI"/>
               </a:rPr>
-              <a:t>Streamlit CSR workspace UI</a:t>
+              <a:t>CSR workspace &amp; console</a:t>
             </a:r>
           </a:p>
         </p:txBody>
@@ -22507,7 +22507,7 @@
                 </a:solidFill>
                 <a:latin typeface="Segoe UI"/>
               </a:rPr>
-              <a:t>Master data as Excel workbooks</a:t>
+              <a:t>Governed master-data foundation</a:t>
             </a:r>
           </a:p>
         </p:txBody>
@@ -22596,7 +22596,7 @@
                 </a:solidFill>
                 <a:latin typeface="Segoe UI"/>
               </a:rPr>
-              <a:t>Mock integrations (email / ERP)</a:t>
+              <a:t>ERP &amp; email integrations</a:t>
             </a:r>
           </a:p>
         </p:txBody>
@@ -22685,7 +22685,7 @@
                 </a:solidFill>
                 <a:latin typeface="Segoe UI"/>
               </a:rPr>
-              <a:t>Runs locally — fast to demo &amp; iterate</a:t>
+              <a:t>Audit &amp; governance store</a:t>
             </a:r>
           </a:p>
         </p:txBody>
@@ -23400,7 +23400,7 @@
                 </a:solidFill>
                 <a:latin typeface="Segoe UI"/>
               </a:rPr>
-              <a:t>Production path</a:t>
+              <a:t>Enterprise readiness</a:t>
             </a:r>
           </a:p>
         </p:txBody>
@@ -23489,7 +23489,7 @@
                 </a:solidFill>
                 <a:latin typeface="Segoe UI"/>
               </a:rPr>
-              <a:t>Connect to ERP / MDM / pricing systems</a:t>
+              <a:t>Integrates with ERP / MDM / pricing</a:t>
             </a:r>
           </a:p>
         </p:txBody>
@@ -23578,7 +23578,7 @@
                 </a:solidFill>
                 <a:latin typeface="Segoe UI"/>
               </a:rPr>
-              <a:t>Swap workbooks for live master data</a:t>
+              <a:t>Live master-data connectivity</a:t>
             </a:r>
           </a:p>
         </p:txBody>
@@ -24174,7 +24174,7 @@
                 </a:solidFill>
                 <a:latin typeface="Segoe UI"/>
               </a:rPr>
-              <a:t>A working accelerator today — a clear path to production.</a:t>
+              <a:t>An intelligent orchestration platform for PO-to-fulfillment.</a:t>
             </a:r>
           </a:p>
           <a:p>
@@ -24196,7 +24196,7 @@
                 </a:solidFill>
                 <a:latin typeface="Segoe UI"/>
               </a:rPr>
-              <a:t>Next: connect live systems, add LLM-assisted reasoning, and pilot with real production POs.</a:t>
+              <a:t>Faster orders, protected margins and governed decisions — with human judgement where it matters.</a:t>
             </a:r>
           </a:p>
         </p:txBody>
@@ -24661,7 +24661,7 @@
                 </a:solidFill>
                 <a:latin typeface="Segoe UI"/>
               </a:rPr>
-              <a:t>The business receives a high volume of purchase orders from its customers across </a:t>
+              <a:t>The business receives a high volume of purchase orders from its customers as </a:t>
             </a:r>
           </a:p>
           <a:p>
@@ -24683,7 +24683,7 @@
                 </a:solidFill>
                 <a:latin typeface="Segoe UI"/>
               </a:rPr>
-              <a:t>email, EDI and portals. Every order must be validated, priced, sourced and approved before it can ship — today that work lands on customer-service reps, order by order, line by line.</a:t>
+              <a:t>email, PDF, Excel and scanned documents. Every order must be validated, priced, sourced and approved before it can ship — today that work lands on customer-service reps, order by order, line by line.</a:t>
             </a:r>
           </a:p>
         </p:txBody>
@@ -29626,7 +29626,7 @@
                 </a:solidFill>
                 <a:latin typeface="Segoe UI"/>
               </a:rPr>
-              <a:t>CHANNELS &amp;</a:t>
+              <a:t>CUSTOMER</a:t>
             </a:r>
           </a:p>
           <a:p>
@@ -29645,7 +29645,7 @@
                 </a:solidFill>
                 <a:latin typeface="Segoe UI"/>
               </a:rPr>
-              <a:t>INGESTION</a:t>
+              <a:t>INTERACTION</a:t>
             </a:r>
           </a:p>
         </p:txBody>
@@ -29753,7 +29753,7 @@
                 </a:solidFill>
                 <a:latin typeface="Segoe UI"/>
               </a:rPr>
-              <a:t>Email / PDF</a:t>
+              <a:t>Email PO</a:t>
             </a:r>
           </a:p>
         </p:txBody>
@@ -29817,7 +29817,7 @@
                 </a:solidFill>
                 <a:latin typeface="Segoe UI"/>
               </a:rPr>
-              <a:t>EDI</a:t>
+              <a:t>PDF PO</a:t>
             </a:r>
           </a:p>
         </p:txBody>
@@ -29881,7 +29881,7 @@
                 </a:solidFill>
                 <a:latin typeface="Segoe UI"/>
               </a:rPr>
-              <a:t>Web portal</a:t>
+              <a:t>Excel PO</a:t>
             </a:r>
           </a:p>
         </p:txBody>
@@ -29945,7 +29945,7 @@
                 </a:solidFill>
                 <a:latin typeface="Segoe UI"/>
               </a:rPr>
-              <a:t>Manual entry</a:t>
+              <a:t>Scanned PO</a:t>
             </a:r>
           </a:p>
         </p:txBody>
@@ -30134,7 +30134,7 @@
                 </a:solidFill>
                 <a:latin typeface="Segoe UI"/>
               </a:rPr>
-              <a:t>CSR Workspace  ·  Streamlit</a:t>
+              <a:t>CSR Workspace &amp; Console</a:t>
             </a:r>
           </a:p>
           <a:p>
@@ -33238,7 +33238,7 @@
                 </a:solidFill>
                 <a:latin typeface="Segoe UI"/>
               </a:rPr>
-              <a:t>POC runs on Streamlit + Python with master data as workbooks; production maps to enterprise ERP / MDM, identity and cloud services.</a:t>
+              <a:t>Governed master data drives every decision; the platform integrates with enterprise ERP / MDM, identity and cloud services.</a:t>
             </a:r>
           </a:p>
         </p:txBody>
@@ -33582,7 +33582,7 @@
         <p:spPr>
           <a:xfrm>
             <a:off x="548640" y="1783080"/>
-            <a:ext cx="2331720" cy="1234440"/>
+            <a:ext cx="2331720" cy="1463040"/>
           </a:xfrm>
           <a:prstGeom prst="roundRect">
             <a:avLst>
@@ -33653,13 +33653,13 @@
               </a:spcAft>
             </a:pPr>
             <a:r>
-              <a:rPr sz="1000" b="1" i="0">
+              <a:rPr sz="950" b="1" i="0">
                 <a:solidFill>
                   <a:srgbClr val="FFE600"/>
                 </a:solidFill>
                 <a:latin typeface="Segoe UI"/>
               </a:rPr>
-              <a:t>PO SOURCES</a:t>
+              <a:t>CUSTOMER INTERACTION</a:t>
             </a:r>
           </a:p>
         </p:txBody>
@@ -33721,7 +33721,7 @@
                 </a:solidFill>
                 <a:latin typeface="Segoe UI"/>
               </a:rPr>
-              <a:t>Email / PDF</a:t>
+              <a:t>Email PO</a:t>
             </a:r>
           </a:p>
         </p:txBody>
@@ -33783,7 +33783,7 @@
                 </a:solidFill>
                 <a:latin typeface="Segoe UI"/>
               </a:rPr>
-              <a:t>EDI</a:t>
+              <a:t>PDF PO</a:t>
             </a:r>
           </a:p>
         </p:txBody>
@@ -33845,7 +33845,7 @@
                 </a:solidFill>
                 <a:latin typeface="Segoe UI"/>
               </a:rPr>
-              <a:t>Portal / Manual</a:t>
+              <a:t>Excel PO</a:t>
             </a:r>
           </a:p>
         </p:txBody>
@@ -33858,8 +33858,8 @@
         </p:nvSpPr>
         <p:spPr>
           <a:xfrm>
-            <a:off x="3246120" y="1783080"/>
-            <a:ext cx="5806440" cy="868680"/>
+            <a:off x="713232" y="2980944"/>
+            <a:ext cx="2011680" cy="219456"/>
           </a:xfrm>
           <a:prstGeom prst="roundRect">
             <a:avLst>
@@ -33867,6 +33867,68 @@
             </a:avLst>
           </a:prstGeom>
           <a:solidFill>
+            <a:srgbClr val="14141E"/>
+          </a:solidFill>
+          <a:ln>
+            <a:noFill/>
+          </a:ln>
+          <a:effectLst/>
+        </p:spPr>
+        <p:style>
+          <a:lnRef idx="1">
+            <a:schemeClr val="accent1"/>
+          </a:lnRef>
+          <a:fillRef idx="3">
+            <a:schemeClr val="accent1"/>
+          </a:fillRef>
+          <a:effectRef idx="2">
+            <a:schemeClr val="accent1"/>
+          </a:effectRef>
+          <a:fontRef idx="minor">
+            <a:schemeClr val="lt1"/>
+          </a:fontRef>
+        </p:style>
+        <p:txBody>
+          <a:bodyPr rtlCol="0" anchor="ctr" wrap="square" lIns="54864" rIns="54864" tIns="27432" bIns="27432"/>
+          <a:lstStyle/>
+          <a:p>
+            <a:pPr algn="ctr">
+              <a:spcBef>
+                <a:spcPts val="0"/>
+              </a:spcBef>
+              <a:spcAft>
+                <a:spcPts val="100"/>
+              </a:spcAft>
+            </a:pPr>
+            <a:r>
+              <a:rPr sz="900" b="1" i="0">
+                <a:solidFill>
+                  <a:srgbClr val="B8B8C6"/>
+                </a:solidFill>
+                <a:latin typeface="Segoe UI"/>
+              </a:rPr>
+              <a:t>Scanned PO</a:t>
+            </a:r>
+          </a:p>
+        </p:txBody>
+      </p:sp>
+      <p:sp>
+        <p:nvSpPr>
+          <p:cNvPr id="15" name="Rounded Rectangle 14"/>
+          <p:cNvSpPr/>
+          <p:nvPr/>
+        </p:nvSpPr>
+        <p:spPr>
+          <a:xfrm>
+            <a:off x="3246120" y="1783080"/>
+            <a:ext cx="5806440" cy="868680"/>
+          </a:xfrm>
+          <a:prstGeom prst="roundRect">
+            <a:avLst>
+              <a:gd name="adj" fmla="val 8000"/>
+            </a:avLst>
+          </a:prstGeom>
+          <a:solidFill>
             <a:srgbClr val="2E2E40"/>
           </a:solidFill>
           <a:ln w="12700">
@@ -33900,7 +33962,7 @@
       </p:sp>
       <p:sp>
         <p:nvSpPr>
-          <p:cNvPr id="15" name="TextBox 14"/>
+          <p:cNvPr id="16" name="TextBox 15"/>
           <p:cNvSpPr txBox="1"/>
           <p:nvPr/>
         </p:nvSpPr>
@@ -33945,7 +34007,7 @@
       </p:sp>
       <p:sp>
         <p:nvSpPr>
-          <p:cNvPr id="16" name="TextBox 15"/>
+          <p:cNvPr id="17" name="TextBox 16"/>
           <p:cNvSpPr txBox="1"/>
           <p:nvPr/>
         </p:nvSpPr>
@@ -33983,14 +34045,14 @@
                 </a:solidFill>
                 <a:latin typeface="Segoe UI"/>
               </a:rPr>
-              <a:t>CSR Workspace  —  Streamlit UI  (intake · live agent panels · one-click decisions · audit)</a:t>
-            </a:r>
-          </a:p>
-        </p:txBody>
-      </p:sp>
-      <p:sp>
-        <p:nvSpPr>
-          <p:cNvPr id="17" name="Rounded Rectangle 16"/>
+              <a:t>CSR Workspace &amp; Console  (intake · live agent panels · one-click decisions · audit)</a:t>
+            </a:r>
+          </a:p>
+        </p:txBody>
+      </p:sp>
+      <p:sp>
+        <p:nvSpPr>
+          <p:cNvPr id="18" name="Rounded Rectangle 17"/>
           <p:cNvSpPr/>
           <p:nvPr/>
         </p:nvSpPr>
@@ -34036,7 +34098,7 @@
       </p:sp>
       <p:sp>
         <p:nvSpPr>
-          <p:cNvPr id="18" name="TextBox 17"/>
+          <p:cNvPr id="19" name="TextBox 18"/>
           <p:cNvSpPr txBox="1"/>
           <p:nvPr/>
         </p:nvSpPr>
@@ -34081,7 +34143,7 @@
       </p:sp>
       <p:sp>
         <p:nvSpPr>
-          <p:cNvPr id="19" name="Rounded Rectangle 18"/>
+          <p:cNvPr id="20" name="Rounded Rectangle 19"/>
           <p:cNvSpPr/>
           <p:nvPr/>
         </p:nvSpPr>
@@ -34143,7 +34205,7 @@
       </p:sp>
       <p:sp>
         <p:nvSpPr>
-          <p:cNvPr id="20" name="Rounded Rectangle 19"/>
+          <p:cNvPr id="21" name="Rounded Rectangle 20"/>
           <p:cNvSpPr/>
           <p:nvPr/>
         </p:nvSpPr>
@@ -34205,7 +34267,7 @@
       </p:sp>
       <p:sp>
         <p:nvSpPr>
-          <p:cNvPr id="21" name="Rounded Rectangle 20"/>
+          <p:cNvPr id="22" name="Rounded Rectangle 21"/>
           <p:cNvSpPr/>
           <p:nvPr/>
         </p:nvSpPr>
@@ -34267,7 +34329,7 @@
       </p:sp>
       <p:sp>
         <p:nvSpPr>
-          <p:cNvPr id="22" name="Rounded Rectangle 21"/>
+          <p:cNvPr id="23" name="Rounded Rectangle 22"/>
           <p:cNvSpPr/>
           <p:nvPr/>
         </p:nvSpPr>
@@ -34329,7 +34391,7 @@
       </p:sp>
       <p:sp>
         <p:nvSpPr>
-          <p:cNvPr id="23" name="Rounded Rectangle 22"/>
+          <p:cNvPr id="24" name="Rounded Rectangle 23"/>
           <p:cNvSpPr/>
           <p:nvPr/>
         </p:nvSpPr>
@@ -34375,7 +34437,7 @@
       </p:sp>
       <p:sp>
         <p:nvSpPr>
-          <p:cNvPr id="24" name="Rectangle 23"/>
+          <p:cNvPr id="25" name="Rectangle 24"/>
           <p:cNvSpPr/>
           <p:nvPr/>
         </p:nvSpPr>
@@ -34419,7 +34481,7 @@
       </p:sp>
       <p:sp>
         <p:nvSpPr>
-          <p:cNvPr id="25" name="TextBox 24"/>
+          <p:cNvPr id="26" name="TextBox 25"/>
           <p:cNvSpPr txBox="1"/>
           <p:nvPr/>
         </p:nvSpPr>
@@ -34473,7 +34535,7 @@
       </p:sp>
       <p:sp>
         <p:nvSpPr>
-          <p:cNvPr id="26" name="Rounded Rectangle 25"/>
+          <p:cNvPr id="27" name="Rounded Rectangle 26"/>
           <p:cNvSpPr/>
           <p:nvPr/>
         </p:nvSpPr>
@@ -34537,7 +34599,7 @@
       </p:sp>
       <p:sp>
         <p:nvSpPr>
-          <p:cNvPr id="27" name="Rounded Rectangle 26"/>
+          <p:cNvPr id="28" name="Rounded Rectangle 27"/>
           <p:cNvSpPr/>
           <p:nvPr/>
         </p:nvSpPr>
@@ -34601,7 +34663,7 @@
       </p:sp>
       <p:sp>
         <p:nvSpPr>
-          <p:cNvPr id="28" name="Rounded Rectangle 27"/>
+          <p:cNvPr id="29" name="Rounded Rectangle 28"/>
           <p:cNvSpPr/>
           <p:nvPr/>
         </p:nvSpPr>
@@ -34665,7 +34727,7 @@
       </p:sp>
       <p:sp>
         <p:nvSpPr>
-          <p:cNvPr id="29" name="Rounded Rectangle 28"/>
+          <p:cNvPr id="30" name="Rounded Rectangle 29"/>
           <p:cNvSpPr/>
           <p:nvPr/>
         </p:nvSpPr>
@@ -34748,7 +34810,7 @@
       </p:sp>
       <p:sp>
         <p:nvSpPr>
-          <p:cNvPr id="30" name="Rounded Rectangle 29"/>
+          <p:cNvPr id="31" name="Rounded Rectangle 30"/>
           <p:cNvSpPr/>
           <p:nvPr/>
         </p:nvSpPr>
@@ -34831,7 +34893,7 @@
       </p:sp>
       <p:sp>
         <p:nvSpPr>
-          <p:cNvPr id="31" name="Rounded Rectangle 30"/>
+          <p:cNvPr id="32" name="Rounded Rectangle 31"/>
           <p:cNvSpPr/>
           <p:nvPr/>
         </p:nvSpPr>
@@ -34914,7 +34976,7 @@
       </p:sp>
       <p:sp>
         <p:nvSpPr>
-          <p:cNvPr id="32" name="Rounded Rectangle 31"/>
+          <p:cNvPr id="33" name="Rounded Rectangle 32"/>
           <p:cNvSpPr/>
           <p:nvPr/>
         </p:nvSpPr>
@@ -34960,7 +35022,7 @@
       </p:sp>
       <p:sp>
         <p:nvSpPr>
-          <p:cNvPr id="33" name="TextBox 32"/>
+          <p:cNvPr id="34" name="TextBox 33"/>
           <p:cNvSpPr txBox="1"/>
           <p:nvPr/>
         </p:nvSpPr>
@@ -35005,7 +35067,7 @@
       </p:sp>
       <p:sp>
         <p:nvSpPr>
-          <p:cNvPr id="34" name="Rounded Rectangle 33"/>
+          <p:cNvPr id="35" name="Rounded Rectangle 34"/>
           <p:cNvSpPr/>
           <p:nvPr/>
         </p:nvSpPr>
@@ -35069,7 +35131,7 @@
       </p:sp>
       <p:sp>
         <p:nvSpPr>
-          <p:cNvPr id="35" name="Rounded Rectangle 34"/>
+          <p:cNvPr id="36" name="Rounded Rectangle 35"/>
           <p:cNvSpPr/>
           <p:nvPr/>
         </p:nvSpPr>
@@ -35133,7 +35195,7 @@
       </p:sp>
       <p:sp>
         <p:nvSpPr>
-          <p:cNvPr id="36" name="Rounded Rectangle 35"/>
+          <p:cNvPr id="37" name="Rounded Rectangle 36"/>
           <p:cNvSpPr/>
           <p:nvPr/>
         </p:nvSpPr>
@@ -35197,7 +35259,7 @@
       </p:sp>
       <p:sp>
         <p:nvSpPr>
-          <p:cNvPr id="37" name="Rounded Rectangle 36"/>
+          <p:cNvPr id="38" name="Rounded Rectangle 37"/>
           <p:cNvSpPr/>
           <p:nvPr/>
         </p:nvSpPr>
@@ -35261,7 +35323,7 @@
       </p:sp>
       <p:sp>
         <p:nvSpPr>
-          <p:cNvPr id="38" name="Rounded Rectangle 37"/>
+          <p:cNvPr id="39" name="Rounded Rectangle 38"/>
           <p:cNvSpPr/>
           <p:nvPr/>
         </p:nvSpPr>
@@ -35325,7 +35387,7 @@
       </p:sp>
       <p:sp>
         <p:nvSpPr>
-          <p:cNvPr id="39" name="Rounded Rectangle 38"/>
+          <p:cNvPr id="40" name="Rounded Rectangle 39"/>
           <p:cNvSpPr/>
           <p:nvPr/>
         </p:nvSpPr>
@@ -35389,7 +35451,7 @@
       </p:sp>
       <p:sp>
         <p:nvSpPr>
-          <p:cNvPr id="40" name="Rounded Rectangle 39"/>
+          <p:cNvPr id="41" name="Rounded Rectangle 40"/>
           <p:cNvSpPr/>
           <p:nvPr/>
         </p:nvSpPr>
@@ -35453,7 +35515,7 @@
       </p:sp>
       <p:sp>
         <p:nvSpPr>
-          <p:cNvPr id="41" name="Rounded Rectangle 40"/>
+          <p:cNvPr id="42" name="Rounded Rectangle 41"/>
           <p:cNvSpPr/>
           <p:nvPr/>
         </p:nvSpPr>
@@ -35517,7 +35579,7 @@
       </p:sp>
       <p:cxnSp>
         <p:nvCxnSpPr>
-          <p:cNvPr id="42" name="Connector 41"/>
+          <p:cNvPr id="43" name="Connector 42"/>
           <p:cNvCxnSpPr/>
           <p:nvPr/>
         </p:nvCxnSpPr>
@@ -35554,7 +35616,7 @@
       </p:cxnSp>
       <p:cxnSp>
         <p:nvCxnSpPr>
-          <p:cNvPr id="43" name="Connector 42"/>
+          <p:cNvPr id="44" name="Connector 43"/>
           <p:cNvCxnSpPr/>
           <p:nvPr/>
         </p:nvCxnSpPr>
@@ -35592,7 +35654,7 @@
       </p:cxnSp>
       <p:cxnSp>
         <p:nvCxnSpPr>
-          <p:cNvPr id="44" name="Connector 43"/>
+          <p:cNvPr id="45" name="Connector 44"/>
           <p:cNvCxnSpPr/>
           <p:nvPr/>
         </p:nvCxnSpPr>
@@ -35630,7 +35692,7 @@
       </p:cxnSp>
       <p:cxnSp>
         <p:nvCxnSpPr>
-          <p:cNvPr id="45" name="Connector 44"/>
+          <p:cNvPr id="46" name="Connector 45"/>
           <p:cNvCxnSpPr/>
           <p:nvPr/>
         </p:nvCxnSpPr>
@@ -35668,7 +35730,7 @@
       </p:cxnSp>
       <p:sp>
         <p:nvSpPr>
-          <p:cNvPr id="46" name="TextBox 45"/>
+          <p:cNvPr id="47" name="TextBox 46"/>
           <p:cNvSpPr txBox="1"/>
           <p:nvPr/>
         </p:nvSpPr>
@@ -35902,7 +35964,7 @@
                 </a:solidFill>
                 <a:latin typeface="Segoe UI"/>
               </a:rPr>
-              <a:t>Process flowchart</a:t>
+              <a:t>Process flowchart — end to end</a:t>
             </a:r>
           </a:p>
         </p:txBody>
@@ -36043,20 +36105,22 @@
       </p:sp>
       <p:sp>
         <p:nvSpPr>
-          <p:cNvPr id="9" name="Terminator 8"/>
+          <p:cNvPr id="9" name="Rounded Rectangle 8"/>
           <p:cNvSpPr/>
           <p:nvPr/>
         </p:nvSpPr>
         <p:spPr>
           <a:xfrm>
-            <a:off x="2148840" y="1645920"/>
-            <a:ext cx="3566160" cy="457200"/>
-          </a:xfrm>
-          <a:prstGeom prst="flowChartTerminator">
-            <a:avLst/>
-          </a:prstGeom>
-          <a:solidFill>
-            <a:srgbClr val="35C759"/>
+            <a:off x="548640" y="1536192"/>
+            <a:ext cx="6858000" cy="457200"/>
+          </a:xfrm>
+          <a:prstGeom prst="roundRect">
+            <a:avLst>
+              <a:gd name="adj" fmla="val 8000"/>
+            </a:avLst>
+          </a:prstGeom>
+          <a:solidFill>
+            <a:srgbClr val="2E2E40"/>
           </a:solidFill>
           <a:ln>
             <a:noFill/>
@@ -36078,6 +36142,97 @@
           </a:fontRef>
         </p:style>
         <p:txBody>
+          <a:bodyPr rtlCol="0" anchor="ctr" wrap="square"/>
+          <a:lstStyle/>
+          <a:p>
+            <a:pPr algn="ctr"/>
+          </a:p>
+        </p:txBody>
+      </p:sp>
+      <p:sp>
+        <p:nvSpPr>
+          <p:cNvPr id="10" name="TextBox 9"/>
+          <p:cNvSpPr txBox="1"/>
+          <p:nvPr/>
+        </p:nvSpPr>
+        <p:spPr>
+          <a:xfrm>
+            <a:off x="685800" y="1636776"/>
+            <a:ext cx="1371600" cy="274320"/>
+          </a:xfrm>
+          <a:prstGeom prst="rect">
+            <a:avLst/>
+          </a:prstGeom>
+          <a:noFill/>
+        </p:spPr>
+        <p:txBody>
+          <a:bodyPr wrap="square" anchor="t" lIns="0" rIns="0" tIns="0" bIns="0">
+            <a:spAutoFit/>
+          </a:bodyPr>
+          <a:lstStyle/>
+          <a:p>
+            <a:pPr algn="l">
+              <a:lnSpc>
+                <a:spcPct val="100000"/>
+              </a:lnSpc>
+              <a:spcBef>
+                <a:spcPts val="0"/>
+              </a:spcBef>
+              <a:spcAft>
+                <a:spcPts val="200"/>
+              </a:spcAft>
+            </a:pPr>
+            <a:r>
+              <a:rPr sz="950" b="1" i="0">
+                <a:solidFill>
+                  <a:srgbClr val="FFE600"/>
+                </a:solidFill>
+                <a:latin typeface="Segoe UI"/>
+              </a:rPr>
+              <a:t>PO INTAKE</a:t>
+            </a:r>
+          </a:p>
+        </p:txBody>
+      </p:sp>
+      <p:sp>
+        <p:nvSpPr>
+          <p:cNvPr id="11" name="Rounded Rectangle 10"/>
+          <p:cNvSpPr/>
+          <p:nvPr/>
+        </p:nvSpPr>
+        <p:spPr>
+          <a:xfrm>
+            <a:off x="2057400" y="1609344"/>
+            <a:ext cx="1188720" cy="310896"/>
+          </a:xfrm>
+          <a:prstGeom prst="roundRect">
+            <a:avLst>
+              <a:gd name="adj" fmla="val 8000"/>
+            </a:avLst>
+          </a:prstGeom>
+          <a:solidFill>
+            <a:srgbClr val="14141E"/>
+          </a:solidFill>
+          <a:ln>
+            <a:noFill/>
+          </a:ln>
+          <a:effectLst/>
+        </p:spPr>
+        <p:style>
+          <a:lnRef idx="1">
+            <a:schemeClr val="accent1"/>
+          </a:lnRef>
+          <a:fillRef idx="3">
+            <a:schemeClr val="accent1"/>
+          </a:fillRef>
+          <a:effectRef idx="2">
+            <a:schemeClr val="accent1"/>
+          </a:effectRef>
+          <a:fontRef idx="minor">
+            <a:schemeClr val="lt1"/>
+          </a:fontRef>
+        </p:style>
+        <p:txBody>
           <a:bodyPr rtlCol="0" anchor="ctr" wrap="square" lIns="54864" rIns="54864" tIns="27432" bIns="27432"/>
           <a:lstStyle/>
           <a:p>
@@ -36090,27 +36245,213 @@
               </a:spcAft>
             </a:pPr>
             <a:r>
-              <a:rPr sz="1050" b="1" i="0">
-                <a:solidFill>
-                  <a:srgbClr val="14141E"/>
-                </a:solidFill>
-                <a:latin typeface="Segoe UI"/>
-              </a:rPr>
-              <a:t>PO received</a:t>
-            </a:r>
-          </a:p>
-        </p:txBody>
-      </p:sp>
-      <p:sp>
-        <p:nvSpPr>
-          <p:cNvPr id="10" name="Process 9"/>
+              <a:rPr sz="900" b="1" i="0">
+                <a:solidFill>
+                  <a:srgbClr val="B8B8C6"/>
+                </a:solidFill>
+                <a:latin typeface="Segoe UI"/>
+              </a:rPr>
+              <a:t>Email PO</a:t>
+            </a:r>
+          </a:p>
+        </p:txBody>
+      </p:sp>
+      <p:sp>
+        <p:nvSpPr>
+          <p:cNvPr id="12" name="Rounded Rectangle 11"/>
           <p:cNvSpPr/>
           <p:nvPr/>
         </p:nvSpPr>
         <p:spPr>
           <a:xfrm>
-            <a:off x="2148840" y="2212848"/>
-            <a:ext cx="3566160" cy="548640"/>
+            <a:off x="3355848" y="1609344"/>
+            <a:ext cx="1188720" cy="310896"/>
+          </a:xfrm>
+          <a:prstGeom prst="roundRect">
+            <a:avLst>
+              <a:gd name="adj" fmla="val 8000"/>
+            </a:avLst>
+          </a:prstGeom>
+          <a:solidFill>
+            <a:srgbClr val="14141E"/>
+          </a:solidFill>
+          <a:ln>
+            <a:noFill/>
+          </a:ln>
+          <a:effectLst/>
+        </p:spPr>
+        <p:style>
+          <a:lnRef idx="1">
+            <a:schemeClr val="accent1"/>
+          </a:lnRef>
+          <a:fillRef idx="3">
+            <a:schemeClr val="accent1"/>
+          </a:fillRef>
+          <a:effectRef idx="2">
+            <a:schemeClr val="accent1"/>
+          </a:effectRef>
+          <a:fontRef idx="minor">
+            <a:schemeClr val="lt1"/>
+          </a:fontRef>
+        </p:style>
+        <p:txBody>
+          <a:bodyPr rtlCol="0" anchor="ctr" wrap="square" lIns="54864" rIns="54864" tIns="27432" bIns="27432"/>
+          <a:lstStyle/>
+          <a:p>
+            <a:pPr algn="ctr">
+              <a:spcBef>
+                <a:spcPts val="0"/>
+              </a:spcBef>
+              <a:spcAft>
+                <a:spcPts val="100"/>
+              </a:spcAft>
+            </a:pPr>
+            <a:r>
+              <a:rPr sz="900" b="1" i="0">
+                <a:solidFill>
+                  <a:srgbClr val="B8B8C6"/>
+                </a:solidFill>
+                <a:latin typeface="Segoe UI"/>
+              </a:rPr>
+              <a:t>PDF PO</a:t>
+            </a:r>
+          </a:p>
+        </p:txBody>
+      </p:sp>
+      <p:sp>
+        <p:nvSpPr>
+          <p:cNvPr id="13" name="Rounded Rectangle 12"/>
+          <p:cNvSpPr/>
+          <p:nvPr/>
+        </p:nvSpPr>
+        <p:spPr>
+          <a:xfrm>
+            <a:off x="4654296" y="1609344"/>
+            <a:ext cx="1188720" cy="310896"/>
+          </a:xfrm>
+          <a:prstGeom prst="roundRect">
+            <a:avLst>
+              <a:gd name="adj" fmla="val 8000"/>
+            </a:avLst>
+          </a:prstGeom>
+          <a:solidFill>
+            <a:srgbClr val="14141E"/>
+          </a:solidFill>
+          <a:ln>
+            <a:noFill/>
+          </a:ln>
+          <a:effectLst/>
+        </p:spPr>
+        <p:style>
+          <a:lnRef idx="1">
+            <a:schemeClr val="accent1"/>
+          </a:lnRef>
+          <a:fillRef idx="3">
+            <a:schemeClr val="accent1"/>
+          </a:fillRef>
+          <a:effectRef idx="2">
+            <a:schemeClr val="accent1"/>
+          </a:effectRef>
+          <a:fontRef idx="minor">
+            <a:schemeClr val="lt1"/>
+          </a:fontRef>
+        </p:style>
+        <p:txBody>
+          <a:bodyPr rtlCol="0" anchor="ctr" wrap="square" lIns="54864" rIns="54864" tIns="27432" bIns="27432"/>
+          <a:lstStyle/>
+          <a:p>
+            <a:pPr algn="ctr">
+              <a:spcBef>
+                <a:spcPts val="0"/>
+              </a:spcBef>
+              <a:spcAft>
+                <a:spcPts val="100"/>
+              </a:spcAft>
+            </a:pPr>
+            <a:r>
+              <a:rPr sz="900" b="1" i="0">
+                <a:solidFill>
+                  <a:srgbClr val="B8B8C6"/>
+                </a:solidFill>
+                <a:latin typeface="Segoe UI"/>
+              </a:rPr>
+              <a:t>Excel PO</a:t>
+            </a:r>
+          </a:p>
+        </p:txBody>
+      </p:sp>
+      <p:sp>
+        <p:nvSpPr>
+          <p:cNvPr id="14" name="Rounded Rectangle 13"/>
+          <p:cNvSpPr/>
+          <p:nvPr/>
+        </p:nvSpPr>
+        <p:spPr>
+          <a:xfrm>
+            <a:off x="5952744" y="1609344"/>
+            <a:ext cx="1188720" cy="310896"/>
+          </a:xfrm>
+          <a:prstGeom prst="roundRect">
+            <a:avLst>
+              <a:gd name="adj" fmla="val 8000"/>
+            </a:avLst>
+          </a:prstGeom>
+          <a:solidFill>
+            <a:srgbClr val="14141E"/>
+          </a:solidFill>
+          <a:ln>
+            <a:noFill/>
+          </a:ln>
+          <a:effectLst/>
+        </p:spPr>
+        <p:style>
+          <a:lnRef idx="1">
+            <a:schemeClr val="accent1"/>
+          </a:lnRef>
+          <a:fillRef idx="3">
+            <a:schemeClr val="accent1"/>
+          </a:fillRef>
+          <a:effectRef idx="2">
+            <a:schemeClr val="accent1"/>
+          </a:effectRef>
+          <a:fontRef idx="minor">
+            <a:schemeClr val="lt1"/>
+          </a:fontRef>
+        </p:style>
+        <p:txBody>
+          <a:bodyPr rtlCol="0" anchor="ctr" wrap="square" lIns="54864" rIns="54864" tIns="27432" bIns="27432"/>
+          <a:lstStyle/>
+          <a:p>
+            <a:pPr algn="ctr">
+              <a:spcBef>
+                <a:spcPts val="0"/>
+              </a:spcBef>
+              <a:spcAft>
+                <a:spcPts val="100"/>
+              </a:spcAft>
+            </a:pPr>
+            <a:r>
+              <a:rPr sz="900" b="1" i="0">
+                <a:solidFill>
+                  <a:srgbClr val="B8B8C6"/>
+                </a:solidFill>
+                <a:latin typeface="Segoe UI"/>
+              </a:rPr>
+              <a:t>Scanned PO</a:t>
+            </a:r>
+          </a:p>
+        </p:txBody>
+      </p:sp>
+      <p:sp>
+        <p:nvSpPr>
+          <p:cNvPr id="15" name="Process 14"/>
+          <p:cNvSpPr/>
+          <p:nvPr/>
+        </p:nvSpPr>
+        <p:spPr>
+          <a:xfrm>
+            <a:off x="1554480" y="2212848"/>
+            <a:ext cx="3657600" cy="402336"/>
           </a:xfrm>
           <a:prstGeom prst="flowChartProcess">
             <a:avLst/>
@@ -36152,27 +36493,89 @@
               </a:spcAft>
             </a:pPr>
             <a:r>
-              <a:rPr sz="1050" b="1" i="0">
+              <a:rPr sz="950" b="1" i="0">
                 <a:solidFill>
                   <a:srgbClr val="FFFFFF"/>
                 </a:solidFill>
                 <a:latin typeface="Segoe UI"/>
               </a:rPr>
-              <a:t>Intake — extract &amp; reconcile vs master data</a:t>
-            </a:r>
-          </a:p>
-        </p:txBody>
-      </p:sp>
-      <p:sp>
-        <p:nvSpPr>
-          <p:cNvPr id="11" name="Decision 10"/>
+              <a:t>Intake — digitise &amp; extract PO</a:t>
+            </a:r>
+          </a:p>
+        </p:txBody>
+      </p:sp>
+      <p:sp>
+        <p:nvSpPr>
+          <p:cNvPr id="16" name="Process 15"/>
           <p:cNvSpPr/>
           <p:nvPr/>
         </p:nvSpPr>
         <p:spPr>
           <a:xfrm>
-            <a:off x="2560320" y="2852928"/>
-            <a:ext cx="2743200" cy="777240"/>
+            <a:off x="1554480" y="2724912"/>
+            <a:ext cx="3657600" cy="402336"/>
+          </a:xfrm>
+          <a:prstGeom prst="flowChartProcess">
+            <a:avLst/>
+          </a:prstGeom>
+          <a:solidFill>
+            <a:srgbClr val="2E2E40"/>
+          </a:solidFill>
+          <a:ln w="12700">
+            <a:solidFill>
+              <a:srgbClr val="3C3C4E"/>
+            </a:solidFill>
+          </a:ln>
+          <a:effectLst/>
+        </p:spPr>
+        <p:style>
+          <a:lnRef idx="1">
+            <a:schemeClr val="accent1"/>
+          </a:lnRef>
+          <a:fillRef idx="3">
+            <a:schemeClr val="accent1"/>
+          </a:fillRef>
+          <a:effectRef idx="2">
+            <a:schemeClr val="accent1"/>
+          </a:effectRef>
+          <a:fontRef idx="minor">
+            <a:schemeClr val="lt1"/>
+          </a:fontRef>
+        </p:style>
+        <p:txBody>
+          <a:bodyPr rtlCol="0" anchor="ctr" wrap="square" lIns="54864" rIns="54864" tIns="27432" bIns="27432"/>
+          <a:lstStyle/>
+          <a:p>
+            <a:pPr algn="ctr">
+              <a:spcBef>
+                <a:spcPts val="0"/>
+              </a:spcBef>
+              <a:spcAft>
+                <a:spcPts val="100"/>
+              </a:spcAft>
+            </a:pPr>
+            <a:r>
+              <a:rPr sz="950" b="1" i="0">
+                <a:solidFill>
+                  <a:srgbClr val="FFFFFF"/>
+                </a:solidFill>
+                <a:latin typeface="Segoe UI"/>
+              </a:rPr>
+              <a:t>Reconcile every line vs master data</a:t>
+            </a:r>
+          </a:p>
+        </p:txBody>
+      </p:sp>
+      <p:sp>
+        <p:nvSpPr>
+          <p:cNvPr id="17" name="Decision 16"/>
+          <p:cNvSpPr/>
+          <p:nvPr/>
+        </p:nvSpPr>
+        <p:spPr>
+          <a:xfrm>
+            <a:off x="1554480" y="3236976"/>
+            <a:ext cx="3657600" cy="676656"/>
           </a:xfrm>
           <a:prstGeom prst="flowChartDecision">
             <a:avLst/>
@@ -36214,27 +36617,27 @@
               </a:spcAft>
             </a:pPr>
             <a:r>
-              <a:rPr sz="1050" b="1" i="0">
+              <a:rPr sz="950" b="1" i="0">
                 <a:solidFill>
                   <a:srgbClr val="FFFFFF"/>
                 </a:solidFill>
                 <a:latin typeface="Segoe UI"/>
               </a:rPr>
-              <a:t>Intake issues?</a:t>
-            </a:r>
-          </a:p>
-        </p:txBody>
-      </p:sp>
-      <p:sp>
-        <p:nvSpPr>
-          <p:cNvPr id="12" name="Process 11"/>
+              <a:t>Intake issues?  (obsolete SKU · qty · UOM · buyer)</a:t>
+            </a:r>
+          </a:p>
+        </p:txBody>
+      </p:sp>
+      <p:sp>
+        <p:nvSpPr>
+          <p:cNvPr id="18" name="Process 17"/>
           <p:cNvSpPr/>
           <p:nvPr/>
         </p:nvSpPr>
         <p:spPr>
           <a:xfrm>
-            <a:off x="2148840" y="3730752"/>
-            <a:ext cx="3566160" cy="548640"/>
+            <a:off x="1554480" y="4041648"/>
+            <a:ext cx="3657600" cy="402336"/>
           </a:xfrm>
           <a:prstGeom prst="flowChartProcess">
             <a:avLst/>
@@ -36276,27 +36679,89 @@
               </a:spcAft>
             </a:pPr>
             <a:r>
-              <a:rPr sz="1050" b="1" i="0">
+              <a:rPr sz="950" b="1" i="0">
                 <a:solidFill>
                   <a:srgbClr val="FFFFFF"/>
                 </a:solidFill>
                 <a:latin typeface="Segoe UI"/>
               </a:rPr>
-              <a:t>Run decision pipeline (Customer → … → Approvals)</a:t>
-            </a:r>
-          </a:p>
-        </p:txBody>
-      </p:sp>
-      <p:sp>
-        <p:nvSpPr>
-          <p:cNvPr id="13" name="Decision 12"/>
+              <a:t>Validate customer, buyer &amp; product match</a:t>
+            </a:r>
+          </a:p>
+        </p:txBody>
+      </p:sp>
+      <p:sp>
+        <p:nvSpPr>
+          <p:cNvPr id="19" name="Process 18"/>
           <p:cNvSpPr/>
           <p:nvPr/>
         </p:nvSpPr>
         <p:spPr>
           <a:xfrm>
-            <a:off x="2560320" y="4370832"/>
-            <a:ext cx="2743200" cy="777240"/>
+            <a:off x="1554480" y="4553712"/>
+            <a:ext cx="3657600" cy="402336"/>
+          </a:xfrm>
+          <a:prstGeom prst="flowChartProcess">
+            <a:avLst/>
+          </a:prstGeom>
+          <a:solidFill>
+            <a:srgbClr val="2E2E40"/>
+          </a:solidFill>
+          <a:ln w="12700">
+            <a:solidFill>
+              <a:srgbClr val="3C3C4E"/>
+            </a:solidFill>
+          </a:ln>
+          <a:effectLst/>
+        </p:spPr>
+        <p:style>
+          <a:lnRef idx="1">
+            <a:schemeClr val="accent1"/>
+          </a:lnRef>
+          <a:fillRef idx="3">
+            <a:schemeClr val="accent1"/>
+          </a:fillRef>
+          <a:effectRef idx="2">
+            <a:schemeClr val="accent1"/>
+          </a:effectRef>
+          <a:fontRef idx="minor">
+            <a:schemeClr val="lt1"/>
+          </a:fontRef>
+        </p:style>
+        <p:txBody>
+          <a:bodyPr rtlCol="0" anchor="ctr" wrap="square" lIns="54864" rIns="54864" tIns="27432" bIns="27432"/>
+          <a:lstStyle/>
+          <a:p>
+            <a:pPr algn="ctr">
+              <a:spcBef>
+                <a:spcPts val="0"/>
+              </a:spcBef>
+              <a:spcAft>
+                <a:spcPts val="100"/>
+              </a:spcAft>
+            </a:pPr>
+            <a:r>
+              <a:rPr sz="950" b="1" i="0">
+                <a:solidFill>
+                  <a:srgbClr val="FFFFFF"/>
+                </a:solidFill>
+                <a:latin typeface="Segoe UI"/>
+              </a:rPr>
+              <a:t>Price · credit · inventory · logistics checks</a:t>
+            </a:r>
+          </a:p>
+        </p:txBody>
+      </p:sp>
+      <p:sp>
+        <p:nvSpPr>
+          <p:cNvPr id="20" name="Decision 19"/>
+          <p:cNvSpPr/>
+          <p:nvPr/>
+        </p:nvSpPr>
+        <p:spPr>
+          <a:xfrm>
+            <a:off x="1554480" y="5065776"/>
+            <a:ext cx="3657600" cy="676656"/>
           </a:xfrm>
           <a:prstGeom prst="flowChartDecision">
             <a:avLst/>
@@ -36338,89 +36803,27 @@
               </a:spcAft>
             </a:pPr>
             <a:r>
-              <a:rPr sz="1050" b="1" i="0">
+              <a:rPr sz="950" b="1" i="0">
                 <a:solidFill>
                   <a:srgbClr val="FFFFFF"/>
                 </a:solidFill>
                 <a:latin typeface="Segoe UI"/>
               </a:rPr>
-              <a:t>Policy exception?</a:t>
-            </a:r>
-          </a:p>
-        </p:txBody>
-      </p:sp>
-      <p:sp>
-        <p:nvSpPr>
-          <p:cNvPr id="14" name="Process 13"/>
+              <a:t>Policy / approval exception?  (margin · credit · budget)</a:t>
+            </a:r>
+          </a:p>
+        </p:txBody>
+      </p:sp>
+      <p:sp>
+        <p:nvSpPr>
+          <p:cNvPr id="21" name="Terminator 20"/>
           <p:cNvSpPr/>
           <p:nvPr/>
         </p:nvSpPr>
         <p:spPr>
           <a:xfrm>
-            <a:off x="2148840" y="5248656"/>
-            <a:ext cx="3566160" cy="502920"/>
-          </a:xfrm>
-          <a:prstGeom prst="flowChartProcess">
-            <a:avLst/>
-          </a:prstGeom>
-          <a:solidFill>
-            <a:srgbClr val="2E2E40"/>
-          </a:solidFill>
-          <a:ln w="12700">
-            <a:solidFill>
-              <a:srgbClr val="3C3C4E"/>
-            </a:solidFill>
-          </a:ln>
-          <a:effectLst/>
-        </p:spPr>
-        <p:style>
-          <a:lnRef idx="1">
-            <a:schemeClr val="accent1"/>
-          </a:lnRef>
-          <a:fillRef idx="3">
-            <a:schemeClr val="accent1"/>
-          </a:fillRef>
-          <a:effectRef idx="2">
-            <a:schemeClr val="accent1"/>
-          </a:effectRef>
-          <a:fontRef idx="minor">
-            <a:schemeClr val="lt1"/>
-          </a:fontRef>
-        </p:style>
-        <p:txBody>
-          <a:bodyPr rtlCol="0" anchor="ctr" wrap="square" lIns="54864" rIns="54864" tIns="27432" bIns="27432"/>
-          <a:lstStyle/>
-          <a:p>
-            <a:pPr algn="ctr">
-              <a:spcBef>
-                <a:spcPts val="0"/>
-              </a:spcBef>
-              <a:spcAft>
-                <a:spcPts val="100"/>
-              </a:spcAft>
-            </a:pPr>
-            <a:r>
-              <a:rPr sz="1050" b="1" i="0">
-                <a:solidFill>
-                  <a:srgbClr val="FFFFFF"/>
-                </a:solidFill>
-                <a:latin typeface="Segoe UI"/>
-              </a:rPr>
-              <a:t>Order Execution — create sales order</a:t>
-            </a:r>
-          </a:p>
-        </p:txBody>
-      </p:sp>
-      <p:sp>
-        <p:nvSpPr>
-          <p:cNvPr id="15" name="Terminator 14"/>
-          <p:cNvSpPr/>
-          <p:nvPr/>
-        </p:nvSpPr>
-        <p:spPr>
-          <a:xfrm>
-            <a:off x="2148840" y="5852160"/>
-            <a:ext cx="3566160" cy="457200"/>
+            <a:off x="1554480" y="5870448"/>
+            <a:ext cx="3657600" cy="420624"/>
           </a:xfrm>
           <a:prstGeom prst="flowChartTerminator">
             <a:avLst/>
@@ -36460,27 +36863,117 @@
               </a:spcAft>
             </a:pPr>
             <a:r>
-              <a:rPr sz="1050" b="1" i="0">
+              <a:rPr sz="950" b="1" i="0">
                 <a:solidFill>
                   <a:srgbClr val="14141E"/>
                 </a:solidFill>
                 <a:latin typeface="Segoe UI"/>
               </a:rPr>
-              <a:t>Order created + full audit trail</a:t>
-            </a:r>
-          </a:p>
-        </p:txBody>
-      </p:sp>
-      <p:sp>
-        <p:nvSpPr>
-          <p:cNvPr id="16" name="Process 15"/>
+              <a:t>Sales order created  ·  notify  ·  audit trail</a:t>
+            </a:r>
+          </a:p>
+        </p:txBody>
+      </p:sp>
+      <p:sp>
+        <p:nvSpPr>
+          <p:cNvPr id="22" name="TextBox 21"/>
+          <p:cNvSpPr txBox="1"/>
+          <p:nvPr/>
+        </p:nvSpPr>
+        <p:spPr>
+          <a:xfrm>
+            <a:off x="7680960" y="2249424"/>
+            <a:ext cx="3931920" cy="274320"/>
+          </a:xfrm>
+          <a:prstGeom prst="rect">
+            <a:avLst/>
+          </a:prstGeom>
+          <a:noFill/>
+        </p:spPr>
+        <p:txBody>
+          <a:bodyPr wrap="square" anchor="t" lIns="0" rIns="0" tIns="0" bIns="0">
+            <a:spAutoFit/>
+          </a:bodyPr>
+          <a:lstStyle/>
+          <a:p>
+            <a:pPr algn="l">
+              <a:lnSpc>
+                <a:spcPct val="100000"/>
+              </a:lnSpc>
+              <a:spcBef>
+                <a:spcPts val="0"/>
+              </a:spcBef>
+              <a:spcAft>
+                <a:spcPts val="200"/>
+              </a:spcAft>
+            </a:pPr>
+            <a:r>
+              <a:rPr sz="1000" b="1" i="0">
+                <a:solidFill>
+                  <a:srgbClr val="FFE600"/>
+                </a:solidFill>
+                <a:latin typeface="Segoe UI"/>
+              </a:rPr>
+              <a:t>HUMAN-IN-THE-LOOP  ·  CSR</a:t>
+            </a:r>
+          </a:p>
+        </p:txBody>
+      </p:sp>
+      <p:sp>
+        <p:nvSpPr>
+          <p:cNvPr id="23" name="TextBox 22"/>
+          <p:cNvSpPr txBox="1"/>
+          <p:nvPr/>
+        </p:nvSpPr>
+        <p:spPr>
+          <a:xfrm>
+            <a:off x="7680960" y="2542032"/>
+            <a:ext cx="3931920" cy="274320"/>
+          </a:xfrm>
+          <a:prstGeom prst="rect">
+            <a:avLst/>
+          </a:prstGeom>
+          <a:noFill/>
+        </p:spPr>
+        <p:txBody>
+          <a:bodyPr wrap="square" anchor="t" lIns="0" rIns="0" tIns="0" bIns="0">
+            <a:spAutoFit/>
+          </a:bodyPr>
+          <a:lstStyle/>
+          <a:p>
+            <a:pPr algn="l">
+              <a:lnSpc>
+                <a:spcPct val="100000"/>
+              </a:lnSpc>
+              <a:spcBef>
+                <a:spcPts val="0"/>
+              </a:spcBef>
+              <a:spcAft>
+                <a:spcPts val="200"/>
+              </a:spcAft>
+            </a:pPr>
+            <a:r>
+              <a:rPr sz="800" b="0" i="1">
+                <a:solidFill>
+                  <a:srgbClr val="B8B8C6"/>
+                </a:solidFill>
+                <a:latin typeface="Segoe UI"/>
+              </a:rPr>
+              <a:t>Blue = intake resolution    Amber = approval    Red = stop</a:t>
+            </a:r>
+          </a:p>
+        </p:txBody>
+      </p:sp>
+      <p:sp>
+        <p:nvSpPr>
+          <p:cNvPr id="24" name="Process 23"/>
           <p:cNvSpPr/>
           <p:nvPr/>
         </p:nvSpPr>
         <p:spPr>
           <a:xfrm>
-            <a:off x="7223760" y="2761488"/>
-            <a:ext cx="3840480" cy="822960"/>
+            <a:off x="7680960" y="3236976"/>
+            <a:ext cx="3931920" cy="676656"/>
           </a:xfrm>
           <a:prstGeom prst="flowChartProcess">
             <a:avLst/>
@@ -36528,7 +37021,7 @@
                 </a:solidFill>
                 <a:latin typeface="Segoe UI"/>
               </a:rPr>
-              <a:t>CSR resolves gate(s):</a:t>
+              <a:t>CSR resolves the gate</a:t>
             </a:r>
           </a:p>
           <a:p>
@@ -36547,21 +37040,21 @@
                 </a:solidFill>
                 <a:latin typeface="Segoe UI"/>
               </a:rPr>
-              <a:t>substitute · qty · UOM · buyer</a:t>
-            </a:r>
-          </a:p>
-        </p:txBody>
-      </p:sp>
-      <p:sp>
-        <p:nvSpPr>
-          <p:cNvPr id="17" name="Process 16"/>
+              <a:t>substitute · qty · UOM · buyer pick</a:t>
+            </a:r>
+          </a:p>
+        </p:txBody>
+      </p:sp>
+      <p:sp>
+        <p:nvSpPr>
+          <p:cNvPr id="25" name="Process 24"/>
           <p:cNvSpPr/>
           <p:nvPr/>
         </p:nvSpPr>
         <p:spPr>
           <a:xfrm>
-            <a:off x="7223760" y="4279392"/>
-            <a:ext cx="3840480" cy="822960"/>
+            <a:off x="7680960" y="5065776"/>
+            <a:ext cx="3931920" cy="676656"/>
           </a:xfrm>
           <a:prstGeom prst="flowChartProcess">
             <a:avLst/>
@@ -36609,7 +37102,7 @@
                 </a:solidFill>
                 <a:latin typeface="Segoe UI"/>
               </a:rPr>
-              <a:t>CSR decides:</a:t>
+              <a:t>CSR decides</a:t>
             </a:r>
           </a:p>
           <a:p>
@@ -36628,21 +37121,21 @@
                 </a:solidFill>
                 <a:latin typeface="Segoe UI"/>
               </a:rPr>
-              <a:t>Approve · Reject · Notify</a:t>
-            </a:r>
-          </a:p>
-        </p:txBody>
-      </p:sp>
-      <p:sp>
-        <p:nvSpPr>
-          <p:cNvPr id="18" name="Terminator 17"/>
+              <a:t>Approve · Reject · Escalate</a:t>
+            </a:r>
+          </a:p>
+        </p:txBody>
+      </p:sp>
+      <p:sp>
+        <p:nvSpPr>
+          <p:cNvPr id="26" name="Terminator 25"/>
           <p:cNvSpPr/>
           <p:nvPr/>
         </p:nvSpPr>
         <p:spPr>
           <a:xfrm>
-            <a:off x="7223760" y="5394960"/>
-            <a:ext cx="3840480" cy="502920"/>
+            <a:off x="7680960" y="5870448"/>
+            <a:ext cx="3931920" cy="420624"/>
           </a:xfrm>
           <a:prstGeom prst="flowChartTerminator">
             <a:avLst/>
@@ -36682,26 +37175,70 @@
               </a:spcAft>
             </a:pPr>
             <a:r>
-              <a:rPr sz="1050" b="1" i="0">
+              <a:rPr sz="950" b="1" i="0">
                 <a:solidFill>
                   <a:srgbClr val="FFFFFF"/>
                 </a:solidFill>
                 <a:latin typeface="Segoe UI"/>
               </a:rPr>
-              <a:t>Order stopped / routed to team</a:t>
-            </a:r>
+              <a:t>Order stopped / routed to responsible team</a:t>
+            </a:r>
+          </a:p>
+        </p:txBody>
+      </p:sp>
+      <p:sp>
+        <p:nvSpPr>
+          <p:cNvPr id="27" name="Down Arrow 26"/>
+          <p:cNvSpPr/>
+          <p:nvPr/>
+        </p:nvSpPr>
+        <p:spPr>
+          <a:xfrm>
+            <a:off x="3227832" y="1993392"/>
+            <a:ext cx="310896" cy="182880"/>
+          </a:xfrm>
+          <a:prstGeom prst="downArrow">
+            <a:avLst/>
+          </a:prstGeom>
+          <a:solidFill>
+            <a:srgbClr val="FFE600"/>
+          </a:solidFill>
+          <a:ln>
+            <a:noFill/>
+          </a:ln>
+          <a:effectLst/>
+        </p:spPr>
+        <p:style>
+          <a:lnRef idx="1">
+            <a:schemeClr val="accent1"/>
+          </a:lnRef>
+          <a:fillRef idx="3">
+            <a:schemeClr val="accent1"/>
+          </a:fillRef>
+          <a:effectRef idx="2">
+            <a:schemeClr val="accent1"/>
+          </a:effectRef>
+          <a:fontRef idx="minor">
+            <a:schemeClr val="lt1"/>
+          </a:fontRef>
+        </p:style>
+        <p:txBody>
+          <a:bodyPr rtlCol="0" anchor="ctr"/>
+          <a:lstStyle/>
+          <a:p>
+            <a:pPr algn="ctr"/>
           </a:p>
         </p:txBody>
       </p:sp>
       <p:cxnSp>
         <p:nvCxnSpPr>
-          <p:cNvPr id="19" name="Connector 18"/>
+          <p:cNvPr id="28" name="Connector 27"/>
           <p:cNvCxnSpPr/>
           <p:nvPr/>
         </p:nvCxnSpPr>
         <p:spPr>
           <a:xfrm>
-            <a:off x="3931920" y="2103120"/>
+            <a:off x="3383280" y="2615184"/>
             <a:ext cx="0" cy="109728"/>
           </a:xfrm>
           <a:prstGeom prst="line">
@@ -36732,14 +37269,14 @@
       </p:cxnSp>
       <p:cxnSp>
         <p:nvCxnSpPr>
-          <p:cNvPr id="20" name="Connector 19"/>
+          <p:cNvPr id="29" name="Connector 28"/>
           <p:cNvCxnSpPr/>
           <p:nvPr/>
         </p:nvCxnSpPr>
         <p:spPr>
           <a:xfrm>
-            <a:off x="3931920" y="2761488"/>
-            <a:ext cx="0" cy="91440"/>
+            <a:off x="3383280" y="3127248"/>
+            <a:ext cx="0" cy="109728"/>
           </a:xfrm>
           <a:prstGeom prst="line">
             <a:avLst/>
@@ -36769,14 +37306,14 @@
       </p:cxnSp>
       <p:cxnSp>
         <p:nvCxnSpPr>
-          <p:cNvPr id="21" name="Connector 20"/>
+          <p:cNvPr id="30" name="Connector 29"/>
           <p:cNvCxnSpPr/>
           <p:nvPr/>
         </p:nvCxnSpPr>
         <p:spPr>
           <a:xfrm>
-            <a:off x="3931920" y="3630168"/>
-            <a:ext cx="0" cy="100584"/>
+            <a:off x="3383280" y="3913632"/>
+            <a:ext cx="0" cy="128016"/>
           </a:xfrm>
           <a:prstGeom prst="line">
             <a:avLst/>
@@ -36806,14 +37343,14 @@
       </p:cxnSp>
       <p:sp>
         <p:nvSpPr>
-          <p:cNvPr id="22" name="TextBox 21"/>
+          <p:cNvPr id="31" name="TextBox 30"/>
           <p:cNvSpPr txBox="1"/>
           <p:nvPr/>
         </p:nvSpPr>
         <p:spPr>
           <a:xfrm>
-            <a:off x="4005072" y="3648456"/>
-            <a:ext cx="548640" cy="201168"/>
+            <a:off x="3474720" y="3922776"/>
+            <a:ext cx="457200" cy="201168"/>
           </a:xfrm>
           <a:prstGeom prst="rect">
             <a:avLst/>
@@ -36851,14 +37388,14 @@
       </p:sp>
       <p:cxnSp>
         <p:nvCxnSpPr>
-          <p:cNvPr id="23" name="Connector 22"/>
+          <p:cNvPr id="32" name="Connector 31"/>
           <p:cNvCxnSpPr/>
           <p:nvPr/>
         </p:nvCxnSpPr>
         <p:spPr>
           <a:xfrm>
-            <a:off x="3931920" y="4279392"/>
-            <a:ext cx="0" cy="91440"/>
+            <a:off x="3383280" y="4443984"/>
+            <a:ext cx="0" cy="109728"/>
           </a:xfrm>
           <a:prstGeom prst="line">
             <a:avLst/>
@@ -36888,14 +37425,14 @@
       </p:cxnSp>
       <p:cxnSp>
         <p:nvCxnSpPr>
-          <p:cNvPr id="24" name="Connector 23"/>
+          <p:cNvPr id="33" name="Connector 32"/>
           <p:cNvCxnSpPr/>
           <p:nvPr/>
         </p:nvCxnSpPr>
         <p:spPr>
           <a:xfrm>
-            <a:off x="3931920" y="5148072"/>
-            <a:ext cx="0" cy="100584"/>
+            <a:off x="3383280" y="4956048"/>
+            <a:ext cx="0" cy="109728"/>
           </a:xfrm>
           <a:prstGeom prst="line">
             <a:avLst/>
@@ -36923,61 +37460,16 @@
           </a:fontRef>
         </p:style>
       </p:cxnSp>
-      <p:sp>
-        <p:nvSpPr>
-          <p:cNvPr id="25" name="TextBox 24"/>
-          <p:cNvSpPr txBox="1"/>
-          <p:nvPr/>
-        </p:nvSpPr>
-        <p:spPr>
-          <a:xfrm>
-            <a:off x="4005072" y="5157216"/>
-            <a:ext cx="548640" cy="201168"/>
-          </a:xfrm>
-          <a:prstGeom prst="rect">
-            <a:avLst/>
-          </a:prstGeom>
-          <a:noFill/>
-        </p:spPr>
-        <p:txBody>
-          <a:bodyPr wrap="square" anchor="t" lIns="0" rIns="0" tIns="0" bIns="0">
-            <a:spAutoFit/>
-          </a:bodyPr>
-          <a:lstStyle/>
-          <a:p>
-            <a:pPr algn="ctr">
-              <a:lnSpc>
-                <a:spcPct val="100000"/>
-              </a:lnSpc>
-              <a:spcBef>
-                <a:spcPts val="0"/>
-              </a:spcBef>
-              <a:spcAft>
-                <a:spcPts val="200"/>
-              </a:spcAft>
-            </a:pPr>
-            <a:r>
-              <a:rPr sz="850" b="1" i="0">
-                <a:solidFill>
-                  <a:srgbClr val="B8B8C6"/>
-                </a:solidFill>
-                <a:latin typeface="Segoe UI"/>
-              </a:rPr>
-              <a:t>No</a:t>
-            </a:r>
-          </a:p>
-        </p:txBody>
-      </p:sp>
       <p:cxnSp>
         <p:nvCxnSpPr>
-          <p:cNvPr id="26" name="Connector 25"/>
+          <p:cNvPr id="34" name="Connector 33"/>
           <p:cNvCxnSpPr/>
           <p:nvPr/>
         </p:nvCxnSpPr>
         <p:spPr>
           <a:xfrm>
-            <a:off x="3931920" y="5751576"/>
-            <a:ext cx="0" cy="100584"/>
+            <a:off x="3383280" y="5742432"/>
+            <a:ext cx="0" cy="128016"/>
           </a:xfrm>
           <a:prstGeom prst="line">
             <a:avLst/>
@@ -37005,16 +37497,61 @@
           </a:fontRef>
         </p:style>
       </p:cxnSp>
+      <p:sp>
+        <p:nvSpPr>
+          <p:cNvPr id="35" name="TextBox 34"/>
+          <p:cNvSpPr txBox="1"/>
+          <p:nvPr/>
+        </p:nvSpPr>
+        <p:spPr>
+          <a:xfrm>
+            <a:off x="3474720" y="5751576"/>
+            <a:ext cx="457200" cy="201168"/>
+          </a:xfrm>
+          <a:prstGeom prst="rect">
+            <a:avLst/>
+          </a:prstGeom>
+          <a:noFill/>
+        </p:spPr>
+        <p:txBody>
+          <a:bodyPr wrap="square" anchor="t" lIns="0" rIns="0" tIns="0" bIns="0">
+            <a:spAutoFit/>
+          </a:bodyPr>
+          <a:lstStyle/>
+          <a:p>
+            <a:pPr algn="ctr">
+              <a:lnSpc>
+                <a:spcPct val="100000"/>
+              </a:lnSpc>
+              <a:spcBef>
+                <a:spcPts val="0"/>
+              </a:spcBef>
+              <a:spcAft>
+                <a:spcPts val="200"/>
+              </a:spcAft>
+            </a:pPr>
+            <a:r>
+              <a:rPr sz="850" b="1" i="0">
+                <a:solidFill>
+                  <a:srgbClr val="B8B8C6"/>
+                </a:solidFill>
+                <a:latin typeface="Segoe UI"/>
+              </a:rPr>
+              <a:t>No</a:t>
+            </a:r>
+          </a:p>
+        </p:txBody>
+      </p:sp>
       <p:cxnSp>
         <p:nvCxnSpPr>
-          <p:cNvPr id="27" name="Connector 26"/>
+          <p:cNvPr id="36" name="Connector 35"/>
           <p:cNvCxnSpPr/>
           <p:nvPr/>
         </p:nvCxnSpPr>
         <p:spPr>
-          <a:xfrm flipV="1">
-            <a:off x="5303520" y="3172968"/>
-            <a:ext cx="1920240" cy="68580"/>
+          <a:xfrm>
+            <a:off x="5212080" y="3575304"/>
+            <a:ext cx="2468880" cy="0"/>
           </a:xfrm>
           <a:prstGeom prst="line">
             <a:avLst/>
@@ -37044,14 +37581,14 @@
       </p:cxnSp>
       <p:sp>
         <p:nvSpPr>
-          <p:cNvPr id="28" name="TextBox 27"/>
+          <p:cNvPr id="37" name="TextBox 36"/>
           <p:cNvSpPr txBox="1"/>
           <p:nvPr/>
         </p:nvSpPr>
         <p:spPr>
           <a:xfrm>
-            <a:off x="5440680" y="2926080"/>
-            <a:ext cx="640080" cy="201168"/>
+            <a:off x="5285232" y="3346704"/>
+            <a:ext cx="548640" cy="201168"/>
           </a:xfrm>
           <a:prstGeom prst="rect">
             <a:avLst/>
@@ -37089,14 +37626,14 @@
       </p:sp>
       <p:cxnSp>
         <p:nvCxnSpPr>
-          <p:cNvPr id="29" name="Connector 28"/>
+          <p:cNvPr id="38" name="Connector 37"/>
           <p:cNvCxnSpPr/>
           <p:nvPr/>
         </p:nvCxnSpPr>
         <p:spPr>
           <a:xfrm flipH="1">
-            <a:off x="6903720" y="3566160"/>
-            <a:ext cx="320040" cy="0"/>
+            <a:off x="6035040" y="3794760"/>
+            <a:ext cx="1645920" cy="0"/>
           </a:xfrm>
           <a:prstGeom prst="line">
             <a:avLst/>
@@ -37125,14 +37662,14 @@
       </p:cxnSp>
       <p:cxnSp>
         <p:nvCxnSpPr>
-          <p:cNvPr id="30" name="Connector 29"/>
+          <p:cNvPr id="39" name="Connector 38"/>
           <p:cNvCxnSpPr/>
           <p:nvPr/>
         </p:nvCxnSpPr>
         <p:spPr>
           <a:xfrm>
-            <a:off x="6903720" y="3566160"/>
-            <a:ext cx="0" cy="438912"/>
+            <a:off x="6035040" y="3794760"/>
+            <a:ext cx="0" cy="448056"/>
           </a:xfrm>
           <a:prstGeom prst="line">
             <a:avLst/>
@@ -37161,14 +37698,14 @@
       </p:cxnSp>
       <p:cxnSp>
         <p:nvCxnSpPr>
-          <p:cNvPr id="31" name="Connector 30"/>
+          <p:cNvPr id="40" name="Connector 39"/>
           <p:cNvCxnSpPr/>
           <p:nvPr/>
         </p:nvCxnSpPr>
         <p:spPr>
           <a:xfrm flipH="1">
-            <a:off x="3931920" y="4005072"/>
-            <a:ext cx="2971800" cy="0"/>
+            <a:off x="5212080" y="4242816"/>
+            <a:ext cx="822960" cy="0"/>
           </a:xfrm>
           <a:prstGeom prst="line">
             <a:avLst/>
@@ -37198,14 +37735,14 @@
       </p:cxnSp>
       <p:sp>
         <p:nvSpPr>
-          <p:cNvPr id="32" name="TextBox 31"/>
+          <p:cNvPr id="41" name="TextBox 40"/>
           <p:cNvSpPr txBox="1"/>
           <p:nvPr/>
         </p:nvSpPr>
         <p:spPr>
           <a:xfrm>
-            <a:off x="5394960" y="3785615"/>
-            <a:ext cx="1463040" cy="201168"/>
+            <a:off x="5440680" y="3602736"/>
+            <a:ext cx="1554480" cy="201168"/>
           </a:xfrm>
           <a:prstGeom prst="rect">
             <a:avLst/>
@@ -37243,14 +37780,14 @@
       </p:sp>
       <p:cxnSp>
         <p:nvCxnSpPr>
-          <p:cNvPr id="33" name="Connector 32"/>
+          <p:cNvPr id="42" name="Connector 41"/>
           <p:cNvCxnSpPr/>
           <p:nvPr/>
         </p:nvCxnSpPr>
         <p:spPr>
-          <a:xfrm flipV="1">
-            <a:off x="5303520" y="4690872"/>
-            <a:ext cx="1920240" cy="68580"/>
+          <a:xfrm>
+            <a:off x="5212080" y="5404104"/>
+            <a:ext cx="2468880" cy="0"/>
           </a:xfrm>
           <a:prstGeom prst="line">
             <a:avLst/>
@@ -37280,14 +37817,14 @@
       </p:cxnSp>
       <p:sp>
         <p:nvSpPr>
-          <p:cNvPr id="34" name="TextBox 33"/>
+          <p:cNvPr id="43" name="TextBox 42"/>
           <p:cNvSpPr txBox="1"/>
           <p:nvPr/>
         </p:nvSpPr>
         <p:spPr>
           <a:xfrm>
-            <a:off x="5440680" y="4443984"/>
-            <a:ext cx="640080" cy="201168"/>
+            <a:off x="5285232" y="5175504"/>
+            <a:ext cx="548640" cy="201168"/>
           </a:xfrm>
           <a:prstGeom prst="rect">
             <a:avLst/>
@@ -37325,14 +37862,14 @@
       </p:sp>
       <p:cxnSp>
         <p:nvCxnSpPr>
-          <p:cNvPr id="35" name="Connector 34"/>
+          <p:cNvPr id="44" name="Connector 43"/>
           <p:cNvCxnSpPr/>
           <p:nvPr/>
         </p:nvCxnSpPr>
         <p:spPr>
           <a:xfrm flipH="1">
-            <a:off x="6903720" y="5102352"/>
-            <a:ext cx="320040" cy="0"/>
+            <a:off x="6035040" y="5623560"/>
+            <a:ext cx="1645920" cy="0"/>
           </a:xfrm>
           <a:prstGeom prst="line">
             <a:avLst/>
@@ -37361,14 +37898,14 @@
       </p:cxnSp>
       <p:cxnSp>
         <p:nvCxnSpPr>
-          <p:cNvPr id="36" name="Connector 35"/>
+          <p:cNvPr id="45" name="Connector 44"/>
           <p:cNvCxnSpPr/>
           <p:nvPr/>
         </p:nvCxnSpPr>
         <p:spPr>
           <a:xfrm>
-            <a:off x="6903720" y="5102352"/>
-            <a:ext cx="0" cy="397764"/>
+            <a:off x="6035040" y="5623560"/>
+            <a:ext cx="0" cy="457200"/>
           </a:xfrm>
           <a:prstGeom prst="line">
             <a:avLst/>
@@ -37397,14 +37934,14 @@
       </p:cxnSp>
       <p:cxnSp>
         <p:nvCxnSpPr>
-          <p:cNvPr id="37" name="Connector 36"/>
+          <p:cNvPr id="46" name="Connector 45"/>
           <p:cNvCxnSpPr/>
           <p:nvPr/>
         </p:nvCxnSpPr>
         <p:spPr>
           <a:xfrm flipH="1">
-            <a:off x="5715000" y="5500116"/>
-            <a:ext cx="1188720" cy="0"/>
+            <a:off x="5212080" y="6080760"/>
+            <a:ext cx="822960" cy="0"/>
           </a:xfrm>
           <a:prstGeom prst="line">
             <a:avLst/>
@@ -37434,14 +37971,14 @@
       </p:cxnSp>
       <p:sp>
         <p:nvSpPr>
-          <p:cNvPr id="38" name="TextBox 37"/>
+          <p:cNvPr id="47" name="TextBox 46"/>
           <p:cNvSpPr txBox="1"/>
           <p:nvPr/>
         </p:nvSpPr>
         <p:spPr>
           <a:xfrm>
-            <a:off x="5852160" y="5285232"/>
-            <a:ext cx="1371600" cy="201168"/>
+            <a:off x="5440680" y="6089904"/>
+            <a:ext cx="1554480" cy="201168"/>
           </a:xfrm>
           <a:prstGeom prst="rect">
             <a:avLst/>
@@ -37479,14 +38016,14 @@
       </p:sp>
       <p:cxnSp>
         <p:nvCxnSpPr>
-          <p:cNvPr id="39" name="Connector 38"/>
+          <p:cNvPr id="48" name="Connector 47"/>
           <p:cNvCxnSpPr/>
           <p:nvPr/>
         </p:nvCxnSpPr>
         <p:spPr>
           <a:xfrm>
-            <a:off x="9144000" y="5102352"/>
-            <a:ext cx="0" cy="292608"/>
+            <a:off x="9646920" y="5742432"/>
+            <a:ext cx="0" cy="128016"/>
           </a:xfrm>
           <a:prstGeom prst="line">
             <a:avLst/>
@@ -37516,14 +38053,14 @@
       </p:cxnSp>
       <p:sp>
         <p:nvSpPr>
-          <p:cNvPr id="40" name="TextBox 39"/>
+          <p:cNvPr id="49" name="TextBox 48"/>
           <p:cNvSpPr txBox="1"/>
           <p:nvPr/>
         </p:nvSpPr>
         <p:spPr>
           <a:xfrm>
-            <a:off x="9235440" y="5120640"/>
-            <a:ext cx="822960" cy="201168"/>
+            <a:off x="9738360" y="5742432"/>
+            <a:ext cx="640080" cy="201168"/>
           </a:xfrm>
           <a:prstGeom prst="rect">
             <a:avLst/>

</xml_diff>

<commit_message>
docs: remove "Platform & enterprise readiness" slide from architecture deck
Deck is now 20 slides.

Co-authored-by: Cursor <cursoragent@cursor.com>
</commit_message>
<xml_diff>
--- a/demo/PO-Fulfillment-Orchestration-Architecture.pptx
+++ b/demo/PO-Fulfillment-Orchestration-Architecture.pptx
@@ -25,7 +25,6 @@
     <p:sldId id="273" r:id="rId24"/>
     <p:sldId id="274" r:id="rId25"/>
     <p:sldId id="275" r:id="rId26"/>
-    <p:sldId id="276" r:id="rId27"/>
   </p:sldIdLst>
   <p:sldSz cx="12191695" cy="6858000" type="screen4x3"/>
   <p:notesSz cx="6858000" cy="9144000"/>
@@ -21789,2076 +21788,6 @@
 </file>
 
 <file path=ppt/slides/slide20.xml><?xml version="1.0" encoding="utf-8"?>
-<p:sld xmlns:a="http://schemas.openxmlformats.org/drawingml/2006/main" xmlns:p="http://schemas.openxmlformats.org/presentationml/2006/main" xmlns:r="http://schemas.openxmlformats.org/officeDocument/2006/relationships">
-  <p:cSld>
-    <p:spTree>
-      <p:nvGrpSpPr>
-        <p:cNvPr id="1" name=""/>
-        <p:cNvGrpSpPr/>
-        <p:nvPr/>
-      </p:nvGrpSpPr>
-      <p:grpSpPr/>
-      <p:sp>
-        <p:nvSpPr>
-          <p:cNvPr id="2" name="Rectangle 1"/>
-          <p:cNvSpPr/>
-          <p:nvPr/>
-        </p:nvSpPr>
-        <p:spPr>
-          <a:xfrm>
-            <a:off x="0" y="0"/>
-            <a:ext cx="12191695" cy="6858000"/>
-          </a:xfrm>
-          <a:prstGeom prst="rect">
-            <a:avLst/>
-          </a:prstGeom>
-          <a:solidFill>
-            <a:srgbClr val="14141E"/>
-          </a:solidFill>
-          <a:ln>
-            <a:noFill/>
-          </a:ln>
-          <a:effectLst/>
-        </p:spPr>
-        <p:style>
-          <a:lnRef idx="1">
-            <a:schemeClr val="accent1"/>
-          </a:lnRef>
-          <a:fillRef idx="3">
-            <a:schemeClr val="accent1"/>
-          </a:fillRef>
-          <a:effectRef idx="2">
-            <a:schemeClr val="accent1"/>
-          </a:effectRef>
-          <a:fontRef idx="minor">
-            <a:schemeClr val="lt1"/>
-          </a:fontRef>
-        </p:style>
-        <p:txBody>
-          <a:bodyPr rtlCol="0" anchor="ctr"/>
-          <a:lstStyle/>
-          <a:p>
-            <a:pPr algn="ctr"/>
-          </a:p>
-        </p:txBody>
-      </p:sp>
-      <p:sp>
-        <p:nvSpPr>
-          <p:cNvPr id="3" name="Rectangle 2"/>
-          <p:cNvSpPr/>
-          <p:nvPr/>
-        </p:nvSpPr>
-        <p:spPr>
-          <a:xfrm>
-            <a:off x="0" y="0"/>
-            <a:ext cx="146304" cy="6858000"/>
-          </a:xfrm>
-          <a:prstGeom prst="rect">
-            <a:avLst/>
-          </a:prstGeom>
-          <a:solidFill>
-            <a:srgbClr val="FFE600"/>
-          </a:solidFill>
-          <a:ln>
-            <a:noFill/>
-          </a:ln>
-          <a:effectLst/>
-        </p:spPr>
-        <p:style>
-          <a:lnRef idx="1">
-            <a:schemeClr val="accent1"/>
-          </a:lnRef>
-          <a:fillRef idx="3">
-            <a:schemeClr val="accent1"/>
-          </a:fillRef>
-          <a:effectRef idx="2">
-            <a:schemeClr val="accent1"/>
-          </a:effectRef>
-          <a:fontRef idx="minor">
-            <a:schemeClr val="lt1"/>
-          </a:fontRef>
-        </p:style>
-        <p:txBody>
-          <a:bodyPr rtlCol="0" anchor="ctr" wrap="square"/>
-          <a:lstStyle/>
-          <a:p>
-            <a:pPr algn="ctr"/>
-          </a:p>
-        </p:txBody>
-      </p:sp>
-      <p:sp>
-        <p:nvSpPr>
-          <p:cNvPr id="4" name="TextBox 3"/>
-          <p:cNvSpPr txBox="1"/>
-          <p:nvPr/>
-        </p:nvSpPr>
-        <p:spPr>
-          <a:xfrm>
-            <a:off x="548640" y="384048"/>
-            <a:ext cx="10515600" cy="365760"/>
-          </a:xfrm>
-          <a:prstGeom prst="rect">
-            <a:avLst/>
-          </a:prstGeom>
-          <a:noFill/>
-        </p:spPr>
-        <p:txBody>
-          <a:bodyPr wrap="square" anchor="t" lIns="0" rIns="0" tIns="0" bIns="0">
-            <a:spAutoFit/>
-          </a:bodyPr>
-          <a:lstStyle/>
-          <a:p>
-            <a:pPr algn="l">
-              <a:lnSpc>
-                <a:spcPct val="100000"/>
-              </a:lnSpc>
-              <a:spcBef>
-                <a:spcPts val="0"/>
-              </a:spcBef>
-              <a:spcAft>
-                <a:spcPts val="200"/>
-              </a:spcAft>
-            </a:pPr>
-            <a:r>
-              <a:rPr sz="1200" b="1" i="0">
-                <a:solidFill>
-                  <a:srgbClr val="FFE600"/>
-                </a:solidFill>
-                <a:latin typeface="Segoe UI"/>
-              </a:rPr>
-              <a:t>WHAT WE BUILT</a:t>
-            </a:r>
-          </a:p>
-        </p:txBody>
-      </p:sp>
-      <p:sp>
-        <p:nvSpPr>
-          <p:cNvPr id="5" name="TextBox 4"/>
-          <p:cNvSpPr txBox="1"/>
-          <p:nvPr/>
-        </p:nvSpPr>
-        <p:spPr>
-          <a:xfrm>
-            <a:off x="548640" y="658368"/>
-            <a:ext cx="11155680" cy="822960"/>
-          </a:xfrm>
-          <a:prstGeom prst="rect">
-            <a:avLst/>
-          </a:prstGeom>
-          <a:noFill/>
-        </p:spPr>
-        <p:txBody>
-          <a:bodyPr wrap="square" anchor="t" lIns="0" rIns="0" tIns="0" bIns="0">
-            <a:spAutoFit/>
-          </a:bodyPr>
-          <a:lstStyle/>
-          <a:p>
-            <a:pPr algn="l">
-              <a:lnSpc>
-                <a:spcPct val="100000"/>
-              </a:lnSpc>
-              <a:spcBef>
-                <a:spcPts val="0"/>
-              </a:spcBef>
-              <a:spcAft>
-                <a:spcPts val="200"/>
-              </a:spcAft>
-            </a:pPr>
-            <a:r>
-              <a:rPr sz="2900" b="1" i="0">
-                <a:solidFill>
-                  <a:srgbClr val="FFFFFF"/>
-                </a:solidFill>
-                <a:latin typeface="Segoe UI"/>
-              </a:rPr>
-              <a:t>Platform &amp; enterprise readiness</a:t>
-            </a:r>
-          </a:p>
-        </p:txBody>
-      </p:sp>
-      <p:sp>
-        <p:nvSpPr>
-          <p:cNvPr id="6" name="Rectangle 5"/>
-          <p:cNvSpPr/>
-          <p:nvPr/>
-        </p:nvSpPr>
-        <p:spPr>
-          <a:xfrm>
-            <a:off x="566928" y="1417320"/>
-            <a:ext cx="2011680" cy="27432"/>
-          </a:xfrm>
-          <a:prstGeom prst="rect">
-            <a:avLst/>
-          </a:prstGeom>
-          <a:solidFill>
-            <a:srgbClr val="FFE600"/>
-          </a:solidFill>
-          <a:ln>
-            <a:noFill/>
-          </a:ln>
-          <a:effectLst/>
-        </p:spPr>
-        <p:style>
-          <a:lnRef idx="1">
-            <a:schemeClr val="accent1"/>
-          </a:lnRef>
-          <a:fillRef idx="3">
-            <a:schemeClr val="accent1"/>
-          </a:fillRef>
-          <a:effectRef idx="2">
-            <a:schemeClr val="accent1"/>
-          </a:effectRef>
-          <a:fontRef idx="minor">
-            <a:schemeClr val="lt1"/>
-          </a:fontRef>
-        </p:style>
-        <p:txBody>
-          <a:bodyPr rtlCol="0" anchor="ctr" wrap="square"/>
-          <a:lstStyle/>
-          <a:p>
-            <a:pPr algn="ctr"/>
-          </a:p>
-        </p:txBody>
-      </p:sp>
-      <p:sp>
-        <p:nvSpPr>
-          <p:cNvPr id="7" name="TextBox 6"/>
-          <p:cNvSpPr txBox="1"/>
-          <p:nvPr/>
-        </p:nvSpPr>
-        <p:spPr>
-          <a:xfrm>
-            <a:off x="11155680" y="6355080"/>
-            <a:ext cx="822960" cy="365760"/>
-          </a:xfrm>
-          <a:prstGeom prst="rect">
-            <a:avLst/>
-          </a:prstGeom>
-          <a:noFill/>
-        </p:spPr>
-        <p:txBody>
-          <a:bodyPr wrap="square" anchor="t" lIns="0" rIns="0" tIns="0" bIns="0">
-            <a:spAutoFit/>
-          </a:bodyPr>
-          <a:lstStyle/>
-          <a:p>
-            <a:pPr algn="r">
-              <a:lnSpc>
-                <a:spcPct val="100000"/>
-              </a:lnSpc>
-              <a:spcBef>
-                <a:spcPts val="0"/>
-              </a:spcBef>
-              <a:spcAft>
-                <a:spcPts val="200"/>
-              </a:spcAft>
-            </a:pPr>
-            <a:r>
-              <a:rPr sz="1000" b="0" i="0">
-                <a:solidFill>
-                  <a:srgbClr val="8A8A99"/>
-                </a:solidFill>
-                <a:latin typeface="Segoe UI"/>
-              </a:rPr>
-              <a:t>20</a:t>
-            </a:r>
-          </a:p>
-        </p:txBody>
-      </p:sp>
-      <p:sp>
-        <p:nvSpPr>
-          <p:cNvPr id="8" name="TextBox 7"/>
-          <p:cNvSpPr txBox="1"/>
-          <p:nvPr/>
-        </p:nvSpPr>
-        <p:spPr>
-          <a:xfrm>
-            <a:off x="548640" y="6355080"/>
-            <a:ext cx="8229600" cy="365760"/>
-          </a:xfrm>
-          <a:prstGeom prst="rect">
-            <a:avLst/>
-          </a:prstGeom>
-          <a:noFill/>
-        </p:spPr>
-        <p:txBody>
-          <a:bodyPr wrap="square" anchor="t" lIns="0" rIns="0" tIns="0" bIns="0">
-            <a:spAutoFit/>
-          </a:bodyPr>
-          <a:lstStyle/>
-          <a:p>
-            <a:pPr algn="l">
-              <a:lnSpc>
-                <a:spcPct val="100000"/>
-              </a:lnSpc>
-              <a:spcBef>
-                <a:spcPts val="0"/>
-              </a:spcBef>
-              <a:spcAft>
-                <a:spcPts val="200"/>
-              </a:spcAft>
-            </a:pPr>
-            <a:r>
-              <a:rPr sz="900" b="0" i="0">
-                <a:solidFill>
-                  <a:srgbClr val="8A8A99"/>
-                </a:solidFill>
-                <a:latin typeface="Segoe UI"/>
-              </a:rPr>
-              <a:t>Order Assistant AI  ·  PO-to-Fulfillment Orchestration</a:t>
-            </a:r>
-          </a:p>
-        </p:txBody>
-      </p:sp>
-      <p:sp>
-        <p:nvSpPr>
-          <p:cNvPr id="9" name="Rounded Rectangle 8"/>
-          <p:cNvSpPr/>
-          <p:nvPr/>
-        </p:nvSpPr>
-        <p:spPr>
-          <a:xfrm>
-            <a:off x="548640" y="1783080"/>
-            <a:ext cx="3611880" cy="4114800"/>
-          </a:xfrm>
-          <a:prstGeom prst="roundRect">
-            <a:avLst>
-              <a:gd name="adj" fmla="val 8000"/>
-            </a:avLst>
-          </a:prstGeom>
-          <a:solidFill>
-            <a:srgbClr val="242433"/>
-          </a:solidFill>
-          <a:ln>
-            <a:noFill/>
-          </a:ln>
-          <a:effectLst/>
-        </p:spPr>
-        <p:style>
-          <a:lnRef idx="1">
-            <a:schemeClr val="accent1"/>
-          </a:lnRef>
-          <a:fillRef idx="3">
-            <a:schemeClr val="accent1"/>
-          </a:fillRef>
-          <a:effectRef idx="2">
-            <a:schemeClr val="accent1"/>
-          </a:effectRef>
-          <a:fontRef idx="minor">
-            <a:schemeClr val="lt1"/>
-          </a:fontRef>
-        </p:style>
-        <p:txBody>
-          <a:bodyPr rtlCol="0" anchor="ctr" wrap="square"/>
-          <a:lstStyle/>
-          <a:p>
-            <a:pPr algn="ctr"/>
-          </a:p>
-        </p:txBody>
-      </p:sp>
-      <p:sp>
-        <p:nvSpPr>
-          <p:cNvPr id="10" name="Rectangle 9"/>
-          <p:cNvSpPr/>
-          <p:nvPr/>
-        </p:nvSpPr>
-        <p:spPr>
-          <a:xfrm>
-            <a:off x="548640" y="1783080"/>
-            <a:ext cx="3611880" cy="109728"/>
-          </a:xfrm>
-          <a:prstGeom prst="rect">
-            <a:avLst/>
-          </a:prstGeom>
-          <a:solidFill>
-            <a:srgbClr val="35C759"/>
-          </a:solidFill>
-          <a:ln>
-            <a:noFill/>
-          </a:ln>
-          <a:effectLst/>
-        </p:spPr>
-        <p:style>
-          <a:lnRef idx="1">
-            <a:schemeClr val="accent1"/>
-          </a:lnRef>
-          <a:fillRef idx="3">
-            <a:schemeClr val="accent1"/>
-          </a:fillRef>
-          <a:effectRef idx="2">
-            <a:schemeClr val="accent1"/>
-          </a:effectRef>
-          <a:fontRef idx="minor">
-            <a:schemeClr val="lt1"/>
-          </a:fontRef>
-        </p:style>
-        <p:txBody>
-          <a:bodyPr rtlCol="0" anchor="ctr" wrap="square"/>
-          <a:lstStyle/>
-          <a:p>
-            <a:pPr algn="ctr"/>
-          </a:p>
-        </p:txBody>
-      </p:sp>
-      <p:sp>
-        <p:nvSpPr>
-          <p:cNvPr id="11" name="TextBox 10"/>
-          <p:cNvSpPr txBox="1"/>
-          <p:nvPr/>
-        </p:nvSpPr>
-        <p:spPr>
-          <a:xfrm>
-            <a:off x="822959" y="2103120"/>
-            <a:ext cx="3108960" cy="457200"/>
-          </a:xfrm>
-          <a:prstGeom prst="rect">
-            <a:avLst/>
-          </a:prstGeom>
-          <a:noFill/>
-        </p:spPr>
-        <p:txBody>
-          <a:bodyPr wrap="square" anchor="t" lIns="0" rIns="0" tIns="0" bIns="0">
-            <a:spAutoFit/>
-          </a:bodyPr>
-          <a:lstStyle/>
-          <a:p>
-            <a:pPr algn="l">
-              <a:lnSpc>
-                <a:spcPct val="100000"/>
-              </a:lnSpc>
-              <a:spcBef>
-                <a:spcPts val="0"/>
-              </a:spcBef>
-              <a:spcAft>
-                <a:spcPts val="200"/>
-              </a:spcAft>
-            </a:pPr>
-            <a:r>
-              <a:rPr sz="1500" b="1" i="0">
-                <a:solidFill>
-                  <a:srgbClr val="FFFFFF"/>
-                </a:solidFill>
-                <a:latin typeface="Segoe UI"/>
-              </a:rPr>
-              <a:t>Solution components</a:t>
-            </a:r>
-          </a:p>
-        </p:txBody>
-      </p:sp>
-      <p:sp>
-        <p:nvSpPr>
-          <p:cNvPr id="12" name="Oval 11"/>
-          <p:cNvSpPr/>
-          <p:nvPr/>
-        </p:nvSpPr>
-        <p:spPr>
-          <a:xfrm>
-            <a:off x="841247" y="2788920"/>
-            <a:ext cx="128016" cy="128016"/>
-          </a:xfrm>
-          <a:prstGeom prst="ellipse">
-            <a:avLst/>
-          </a:prstGeom>
-          <a:solidFill>
-            <a:srgbClr val="35C759"/>
-          </a:solidFill>
-          <a:ln>
-            <a:noFill/>
-          </a:ln>
-          <a:effectLst/>
-        </p:spPr>
-        <p:style>
-          <a:lnRef idx="1">
-            <a:schemeClr val="accent1"/>
-          </a:lnRef>
-          <a:fillRef idx="3">
-            <a:schemeClr val="accent1"/>
-          </a:fillRef>
-          <a:effectRef idx="2">
-            <a:schemeClr val="accent1"/>
-          </a:effectRef>
-          <a:fontRef idx="minor">
-            <a:schemeClr val="lt1"/>
-          </a:fontRef>
-        </p:style>
-        <p:txBody>
-          <a:bodyPr rtlCol="0" anchor="ctr"/>
-          <a:lstStyle/>
-          <a:p>
-            <a:pPr algn="ctr"/>
-          </a:p>
-        </p:txBody>
-      </p:sp>
-      <p:sp>
-        <p:nvSpPr>
-          <p:cNvPr id="13" name="TextBox 12"/>
-          <p:cNvSpPr txBox="1"/>
-          <p:nvPr/>
-        </p:nvSpPr>
-        <p:spPr>
-          <a:xfrm>
-            <a:off x="1097280" y="2743200"/>
-            <a:ext cx="2834640" cy="548640"/>
-          </a:xfrm>
-          <a:prstGeom prst="rect">
-            <a:avLst/>
-          </a:prstGeom>
-          <a:noFill/>
-        </p:spPr>
-        <p:txBody>
-          <a:bodyPr wrap="square" anchor="t" lIns="0" rIns="0" tIns="0" bIns="0">
-            <a:spAutoFit/>
-          </a:bodyPr>
-          <a:lstStyle/>
-          <a:p>
-            <a:pPr algn="l">
-              <a:lnSpc>
-                <a:spcPct val="100000"/>
-              </a:lnSpc>
-              <a:spcBef>
-                <a:spcPts val="0"/>
-              </a:spcBef>
-              <a:spcAft>
-                <a:spcPts val="200"/>
-              </a:spcAft>
-            </a:pPr>
-            <a:r>
-              <a:rPr sz="1150" b="0" i="0">
-                <a:solidFill>
-                  <a:srgbClr val="B8B8C6"/>
-                </a:solidFill>
-                <a:latin typeface="Segoe UI"/>
-              </a:rPr>
-              <a:t>Agent orchestration engine</a:t>
-            </a:r>
-          </a:p>
-        </p:txBody>
-      </p:sp>
-      <p:sp>
-        <p:nvSpPr>
-          <p:cNvPr id="14" name="Oval 13"/>
-          <p:cNvSpPr/>
-          <p:nvPr/>
-        </p:nvSpPr>
-        <p:spPr>
-          <a:xfrm>
-            <a:off x="841247" y="3410712"/>
-            <a:ext cx="128016" cy="128016"/>
-          </a:xfrm>
-          <a:prstGeom prst="ellipse">
-            <a:avLst/>
-          </a:prstGeom>
-          <a:solidFill>
-            <a:srgbClr val="35C759"/>
-          </a:solidFill>
-          <a:ln>
-            <a:noFill/>
-          </a:ln>
-          <a:effectLst/>
-        </p:spPr>
-        <p:style>
-          <a:lnRef idx="1">
-            <a:schemeClr val="accent1"/>
-          </a:lnRef>
-          <a:fillRef idx="3">
-            <a:schemeClr val="accent1"/>
-          </a:fillRef>
-          <a:effectRef idx="2">
-            <a:schemeClr val="accent1"/>
-          </a:effectRef>
-          <a:fontRef idx="minor">
-            <a:schemeClr val="lt1"/>
-          </a:fontRef>
-        </p:style>
-        <p:txBody>
-          <a:bodyPr rtlCol="0" anchor="ctr"/>
-          <a:lstStyle/>
-          <a:p>
-            <a:pPr algn="ctr"/>
-          </a:p>
-        </p:txBody>
-      </p:sp>
-      <p:sp>
-        <p:nvSpPr>
-          <p:cNvPr id="15" name="TextBox 14"/>
-          <p:cNvSpPr txBox="1"/>
-          <p:nvPr/>
-        </p:nvSpPr>
-        <p:spPr>
-          <a:xfrm>
-            <a:off x="1097280" y="3364992"/>
-            <a:ext cx="2834640" cy="548640"/>
-          </a:xfrm>
-          <a:prstGeom prst="rect">
-            <a:avLst/>
-          </a:prstGeom>
-          <a:noFill/>
-        </p:spPr>
-        <p:txBody>
-          <a:bodyPr wrap="square" anchor="t" lIns="0" rIns="0" tIns="0" bIns="0">
-            <a:spAutoFit/>
-          </a:bodyPr>
-          <a:lstStyle/>
-          <a:p>
-            <a:pPr algn="l">
-              <a:lnSpc>
-                <a:spcPct val="100000"/>
-              </a:lnSpc>
-              <a:spcBef>
-                <a:spcPts val="0"/>
-              </a:spcBef>
-              <a:spcAft>
-                <a:spcPts val="200"/>
-              </a:spcAft>
-            </a:pPr>
-            <a:r>
-              <a:rPr sz="1150" b="0" i="0">
-                <a:solidFill>
-                  <a:srgbClr val="B8B8C6"/>
-                </a:solidFill>
-                <a:latin typeface="Segoe UI"/>
-              </a:rPr>
-              <a:t>CSR workspace &amp; console</a:t>
-            </a:r>
-          </a:p>
-        </p:txBody>
-      </p:sp>
-      <p:sp>
-        <p:nvSpPr>
-          <p:cNvPr id="16" name="Oval 15"/>
-          <p:cNvSpPr/>
-          <p:nvPr/>
-        </p:nvSpPr>
-        <p:spPr>
-          <a:xfrm>
-            <a:off x="841247" y="4032504"/>
-            <a:ext cx="128016" cy="128016"/>
-          </a:xfrm>
-          <a:prstGeom prst="ellipse">
-            <a:avLst/>
-          </a:prstGeom>
-          <a:solidFill>
-            <a:srgbClr val="35C759"/>
-          </a:solidFill>
-          <a:ln>
-            <a:noFill/>
-          </a:ln>
-          <a:effectLst/>
-        </p:spPr>
-        <p:style>
-          <a:lnRef idx="1">
-            <a:schemeClr val="accent1"/>
-          </a:lnRef>
-          <a:fillRef idx="3">
-            <a:schemeClr val="accent1"/>
-          </a:fillRef>
-          <a:effectRef idx="2">
-            <a:schemeClr val="accent1"/>
-          </a:effectRef>
-          <a:fontRef idx="minor">
-            <a:schemeClr val="lt1"/>
-          </a:fontRef>
-        </p:style>
-        <p:txBody>
-          <a:bodyPr rtlCol="0" anchor="ctr"/>
-          <a:lstStyle/>
-          <a:p>
-            <a:pPr algn="ctr"/>
-          </a:p>
-        </p:txBody>
-      </p:sp>
-      <p:sp>
-        <p:nvSpPr>
-          <p:cNvPr id="17" name="TextBox 16"/>
-          <p:cNvSpPr txBox="1"/>
-          <p:nvPr/>
-        </p:nvSpPr>
-        <p:spPr>
-          <a:xfrm>
-            <a:off x="1097280" y="3986784"/>
-            <a:ext cx="2834640" cy="548640"/>
-          </a:xfrm>
-          <a:prstGeom prst="rect">
-            <a:avLst/>
-          </a:prstGeom>
-          <a:noFill/>
-        </p:spPr>
-        <p:txBody>
-          <a:bodyPr wrap="square" anchor="t" lIns="0" rIns="0" tIns="0" bIns="0">
-            <a:spAutoFit/>
-          </a:bodyPr>
-          <a:lstStyle/>
-          <a:p>
-            <a:pPr algn="l">
-              <a:lnSpc>
-                <a:spcPct val="100000"/>
-              </a:lnSpc>
-              <a:spcBef>
-                <a:spcPts val="0"/>
-              </a:spcBef>
-              <a:spcAft>
-                <a:spcPts val="200"/>
-              </a:spcAft>
-            </a:pPr>
-            <a:r>
-              <a:rPr sz="1150" b="0" i="0">
-                <a:solidFill>
-                  <a:srgbClr val="B8B8C6"/>
-                </a:solidFill>
-                <a:latin typeface="Segoe UI"/>
-              </a:rPr>
-              <a:t>Governed master-data foundation</a:t>
-            </a:r>
-          </a:p>
-        </p:txBody>
-      </p:sp>
-      <p:sp>
-        <p:nvSpPr>
-          <p:cNvPr id="18" name="Oval 17"/>
-          <p:cNvSpPr/>
-          <p:nvPr/>
-        </p:nvSpPr>
-        <p:spPr>
-          <a:xfrm>
-            <a:off x="841247" y="4654296"/>
-            <a:ext cx="128016" cy="128016"/>
-          </a:xfrm>
-          <a:prstGeom prst="ellipse">
-            <a:avLst/>
-          </a:prstGeom>
-          <a:solidFill>
-            <a:srgbClr val="35C759"/>
-          </a:solidFill>
-          <a:ln>
-            <a:noFill/>
-          </a:ln>
-          <a:effectLst/>
-        </p:spPr>
-        <p:style>
-          <a:lnRef idx="1">
-            <a:schemeClr val="accent1"/>
-          </a:lnRef>
-          <a:fillRef idx="3">
-            <a:schemeClr val="accent1"/>
-          </a:fillRef>
-          <a:effectRef idx="2">
-            <a:schemeClr val="accent1"/>
-          </a:effectRef>
-          <a:fontRef idx="minor">
-            <a:schemeClr val="lt1"/>
-          </a:fontRef>
-        </p:style>
-        <p:txBody>
-          <a:bodyPr rtlCol="0" anchor="ctr"/>
-          <a:lstStyle/>
-          <a:p>
-            <a:pPr algn="ctr"/>
-          </a:p>
-        </p:txBody>
-      </p:sp>
-      <p:sp>
-        <p:nvSpPr>
-          <p:cNvPr id="19" name="TextBox 18"/>
-          <p:cNvSpPr txBox="1"/>
-          <p:nvPr/>
-        </p:nvSpPr>
-        <p:spPr>
-          <a:xfrm>
-            <a:off x="1097280" y="4608576"/>
-            <a:ext cx="2834640" cy="548640"/>
-          </a:xfrm>
-          <a:prstGeom prst="rect">
-            <a:avLst/>
-          </a:prstGeom>
-          <a:noFill/>
-        </p:spPr>
-        <p:txBody>
-          <a:bodyPr wrap="square" anchor="t" lIns="0" rIns="0" tIns="0" bIns="0">
-            <a:spAutoFit/>
-          </a:bodyPr>
-          <a:lstStyle/>
-          <a:p>
-            <a:pPr algn="l">
-              <a:lnSpc>
-                <a:spcPct val="100000"/>
-              </a:lnSpc>
-              <a:spcBef>
-                <a:spcPts val="0"/>
-              </a:spcBef>
-              <a:spcAft>
-                <a:spcPts val="200"/>
-              </a:spcAft>
-            </a:pPr>
-            <a:r>
-              <a:rPr sz="1150" b="0" i="0">
-                <a:solidFill>
-                  <a:srgbClr val="B8B8C6"/>
-                </a:solidFill>
-                <a:latin typeface="Segoe UI"/>
-              </a:rPr>
-              <a:t>ERP &amp; email integrations</a:t>
-            </a:r>
-          </a:p>
-        </p:txBody>
-      </p:sp>
-      <p:sp>
-        <p:nvSpPr>
-          <p:cNvPr id="20" name="Oval 19"/>
-          <p:cNvSpPr/>
-          <p:nvPr/>
-        </p:nvSpPr>
-        <p:spPr>
-          <a:xfrm>
-            <a:off x="841247" y="5276088"/>
-            <a:ext cx="128016" cy="128016"/>
-          </a:xfrm>
-          <a:prstGeom prst="ellipse">
-            <a:avLst/>
-          </a:prstGeom>
-          <a:solidFill>
-            <a:srgbClr val="35C759"/>
-          </a:solidFill>
-          <a:ln>
-            <a:noFill/>
-          </a:ln>
-          <a:effectLst/>
-        </p:spPr>
-        <p:style>
-          <a:lnRef idx="1">
-            <a:schemeClr val="accent1"/>
-          </a:lnRef>
-          <a:fillRef idx="3">
-            <a:schemeClr val="accent1"/>
-          </a:fillRef>
-          <a:effectRef idx="2">
-            <a:schemeClr val="accent1"/>
-          </a:effectRef>
-          <a:fontRef idx="minor">
-            <a:schemeClr val="lt1"/>
-          </a:fontRef>
-        </p:style>
-        <p:txBody>
-          <a:bodyPr rtlCol="0" anchor="ctr"/>
-          <a:lstStyle/>
-          <a:p>
-            <a:pPr algn="ctr"/>
-          </a:p>
-        </p:txBody>
-      </p:sp>
-      <p:sp>
-        <p:nvSpPr>
-          <p:cNvPr id="21" name="TextBox 20"/>
-          <p:cNvSpPr txBox="1"/>
-          <p:nvPr/>
-        </p:nvSpPr>
-        <p:spPr>
-          <a:xfrm>
-            <a:off x="1097280" y="5230368"/>
-            <a:ext cx="2834640" cy="548640"/>
-          </a:xfrm>
-          <a:prstGeom prst="rect">
-            <a:avLst/>
-          </a:prstGeom>
-          <a:noFill/>
-        </p:spPr>
-        <p:txBody>
-          <a:bodyPr wrap="square" anchor="t" lIns="0" rIns="0" tIns="0" bIns="0">
-            <a:spAutoFit/>
-          </a:bodyPr>
-          <a:lstStyle/>
-          <a:p>
-            <a:pPr algn="l">
-              <a:lnSpc>
-                <a:spcPct val="100000"/>
-              </a:lnSpc>
-              <a:spcBef>
-                <a:spcPts val="0"/>
-              </a:spcBef>
-              <a:spcAft>
-                <a:spcPts val="200"/>
-              </a:spcAft>
-            </a:pPr>
-            <a:r>
-              <a:rPr sz="1150" b="0" i="0">
-                <a:solidFill>
-                  <a:srgbClr val="B8B8C6"/>
-                </a:solidFill>
-                <a:latin typeface="Segoe UI"/>
-              </a:rPr>
-              <a:t>Audit &amp; governance store</a:t>
-            </a:r>
-          </a:p>
-        </p:txBody>
-      </p:sp>
-      <p:sp>
-        <p:nvSpPr>
-          <p:cNvPr id="22" name="Rounded Rectangle 21"/>
-          <p:cNvSpPr/>
-          <p:nvPr/>
-        </p:nvSpPr>
-        <p:spPr>
-          <a:xfrm>
-            <a:off x="4279392" y="1783080"/>
-            <a:ext cx="3611880" cy="4114800"/>
-          </a:xfrm>
-          <a:prstGeom prst="roundRect">
-            <a:avLst>
-              <a:gd name="adj" fmla="val 8000"/>
-            </a:avLst>
-          </a:prstGeom>
-          <a:solidFill>
-            <a:srgbClr val="242433"/>
-          </a:solidFill>
-          <a:ln>
-            <a:noFill/>
-          </a:ln>
-          <a:effectLst/>
-        </p:spPr>
-        <p:style>
-          <a:lnRef idx="1">
-            <a:schemeClr val="accent1"/>
-          </a:lnRef>
-          <a:fillRef idx="3">
-            <a:schemeClr val="accent1"/>
-          </a:fillRef>
-          <a:effectRef idx="2">
-            <a:schemeClr val="accent1"/>
-          </a:effectRef>
-          <a:fontRef idx="minor">
-            <a:schemeClr val="lt1"/>
-          </a:fontRef>
-        </p:style>
-        <p:txBody>
-          <a:bodyPr rtlCol="0" anchor="ctr" wrap="square"/>
-          <a:lstStyle/>
-          <a:p>
-            <a:pPr algn="ctr"/>
-          </a:p>
-        </p:txBody>
-      </p:sp>
-      <p:sp>
-        <p:nvSpPr>
-          <p:cNvPr id="23" name="Rectangle 22"/>
-          <p:cNvSpPr/>
-          <p:nvPr/>
-        </p:nvSpPr>
-        <p:spPr>
-          <a:xfrm>
-            <a:off x="4279392" y="1783080"/>
-            <a:ext cx="3611880" cy="109728"/>
-          </a:xfrm>
-          <a:prstGeom prst="rect">
-            <a:avLst/>
-          </a:prstGeom>
-          <a:solidFill>
-            <a:srgbClr val="FFE600"/>
-          </a:solidFill>
-          <a:ln>
-            <a:noFill/>
-          </a:ln>
-          <a:effectLst/>
-        </p:spPr>
-        <p:style>
-          <a:lnRef idx="1">
-            <a:schemeClr val="accent1"/>
-          </a:lnRef>
-          <a:fillRef idx="3">
-            <a:schemeClr val="accent1"/>
-          </a:fillRef>
-          <a:effectRef idx="2">
-            <a:schemeClr val="accent1"/>
-          </a:effectRef>
-          <a:fontRef idx="minor">
-            <a:schemeClr val="lt1"/>
-          </a:fontRef>
-        </p:style>
-        <p:txBody>
-          <a:bodyPr rtlCol="0" anchor="ctr" wrap="square"/>
-          <a:lstStyle/>
-          <a:p>
-            <a:pPr algn="ctr"/>
-          </a:p>
-        </p:txBody>
-      </p:sp>
-      <p:sp>
-        <p:nvSpPr>
-          <p:cNvPr id="24" name="TextBox 23"/>
-          <p:cNvSpPr txBox="1"/>
-          <p:nvPr/>
-        </p:nvSpPr>
-        <p:spPr>
-          <a:xfrm>
-            <a:off x="4553712" y="2103120"/>
-            <a:ext cx="3108960" cy="457200"/>
-          </a:xfrm>
-          <a:prstGeom prst="rect">
-            <a:avLst/>
-          </a:prstGeom>
-          <a:noFill/>
-        </p:spPr>
-        <p:txBody>
-          <a:bodyPr wrap="square" anchor="t" lIns="0" rIns="0" tIns="0" bIns="0">
-            <a:spAutoFit/>
-          </a:bodyPr>
-          <a:lstStyle/>
-          <a:p>
-            <a:pPr algn="l">
-              <a:lnSpc>
-                <a:spcPct val="100000"/>
-              </a:lnSpc>
-              <a:spcBef>
-                <a:spcPts val="0"/>
-              </a:spcBef>
-              <a:spcAft>
-                <a:spcPts val="200"/>
-              </a:spcAft>
-            </a:pPr>
-            <a:r>
-              <a:rPr sz="1500" b="1" i="0">
-                <a:solidFill>
-                  <a:srgbClr val="FFFFFF"/>
-                </a:solidFill>
-                <a:latin typeface="Segoe UI"/>
-              </a:rPr>
-              <a:t>Architecture principles</a:t>
-            </a:r>
-          </a:p>
-        </p:txBody>
-      </p:sp>
-      <p:sp>
-        <p:nvSpPr>
-          <p:cNvPr id="25" name="Oval 24"/>
-          <p:cNvSpPr/>
-          <p:nvPr/>
-        </p:nvSpPr>
-        <p:spPr>
-          <a:xfrm>
-            <a:off x="4572000" y="2788920"/>
-            <a:ext cx="128016" cy="128016"/>
-          </a:xfrm>
-          <a:prstGeom prst="ellipse">
-            <a:avLst/>
-          </a:prstGeom>
-          <a:solidFill>
-            <a:srgbClr val="FFE600"/>
-          </a:solidFill>
-          <a:ln>
-            <a:noFill/>
-          </a:ln>
-          <a:effectLst/>
-        </p:spPr>
-        <p:style>
-          <a:lnRef idx="1">
-            <a:schemeClr val="accent1"/>
-          </a:lnRef>
-          <a:fillRef idx="3">
-            <a:schemeClr val="accent1"/>
-          </a:fillRef>
-          <a:effectRef idx="2">
-            <a:schemeClr val="accent1"/>
-          </a:effectRef>
-          <a:fontRef idx="minor">
-            <a:schemeClr val="lt1"/>
-          </a:fontRef>
-        </p:style>
-        <p:txBody>
-          <a:bodyPr rtlCol="0" anchor="ctr"/>
-          <a:lstStyle/>
-          <a:p>
-            <a:pPr algn="ctr"/>
-          </a:p>
-        </p:txBody>
-      </p:sp>
-      <p:sp>
-        <p:nvSpPr>
-          <p:cNvPr id="26" name="TextBox 25"/>
-          <p:cNvSpPr txBox="1"/>
-          <p:nvPr/>
-        </p:nvSpPr>
-        <p:spPr>
-          <a:xfrm>
-            <a:off x="4828031" y="2743200"/>
-            <a:ext cx="2834640" cy="548640"/>
-          </a:xfrm>
-          <a:prstGeom prst="rect">
-            <a:avLst/>
-          </a:prstGeom>
-          <a:noFill/>
-        </p:spPr>
-        <p:txBody>
-          <a:bodyPr wrap="square" anchor="t" lIns="0" rIns="0" tIns="0" bIns="0">
-            <a:spAutoFit/>
-          </a:bodyPr>
-          <a:lstStyle/>
-          <a:p>
-            <a:pPr algn="l">
-              <a:lnSpc>
-                <a:spcPct val="100000"/>
-              </a:lnSpc>
-              <a:spcBef>
-                <a:spcPts val="0"/>
-              </a:spcBef>
-              <a:spcAft>
-                <a:spcPts val="200"/>
-              </a:spcAft>
-            </a:pPr>
-            <a:r>
-              <a:rPr sz="1150" b="0" i="0">
-                <a:solidFill>
-                  <a:srgbClr val="B8B8C6"/>
-                </a:solidFill>
-                <a:latin typeface="Segoe UI"/>
-              </a:rPr>
-              <a:t>Modular agents &amp; decision layers</a:t>
-            </a:r>
-          </a:p>
-        </p:txBody>
-      </p:sp>
-      <p:sp>
-        <p:nvSpPr>
-          <p:cNvPr id="27" name="Oval 26"/>
-          <p:cNvSpPr/>
-          <p:nvPr/>
-        </p:nvSpPr>
-        <p:spPr>
-          <a:xfrm>
-            <a:off x="4572000" y="3410712"/>
-            <a:ext cx="128016" cy="128016"/>
-          </a:xfrm>
-          <a:prstGeom prst="ellipse">
-            <a:avLst/>
-          </a:prstGeom>
-          <a:solidFill>
-            <a:srgbClr val="FFE600"/>
-          </a:solidFill>
-          <a:ln>
-            <a:noFill/>
-          </a:ln>
-          <a:effectLst/>
-        </p:spPr>
-        <p:style>
-          <a:lnRef idx="1">
-            <a:schemeClr val="accent1"/>
-          </a:lnRef>
-          <a:fillRef idx="3">
-            <a:schemeClr val="accent1"/>
-          </a:fillRef>
-          <a:effectRef idx="2">
-            <a:schemeClr val="accent1"/>
-          </a:effectRef>
-          <a:fontRef idx="minor">
-            <a:schemeClr val="lt1"/>
-          </a:fontRef>
-        </p:style>
-        <p:txBody>
-          <a:bodyPr rtlCol="0" anchor="ctr"/>
-          <a:lstStyle/>
-          <a:p>
-            <a:pPr algn="ctr"/>
-          </a:p>
-        </p:txBody>
-      </p:sp>
-      <p:sp>
-        <p:nvSpPr>
-          <p:cNvPr id="28" name="TextBox 27"/>
-          <p:cNvSpPr txBox="1"/>
-          <p:nvPr/>
-        </p:nvSpPr>
-        <p:spPr>
-          <a:xfrm>
-            <a:off x="4828031" y="3364992"/>
-            <a:ext cx="2834640" cy="548640"/>
-          </a:xfrm>
-          <a:prstGeom prst="rect">
-            <a:avLst/>
-          </a:prstGeom>
-          <a:noFill/>
-        </p:spPr>
-        <p:txBody>
-          <a:bodyPr wrap="square" anchor="t" lIns="0" rIns="0" tIns="0" bIns="0">
-            <a:spAutoFit/>
-          </a:bodyPr>
-          <a:lstStyle/>
-          <a:p>
-            <a:pPr algn="l">
-              <a:lnSpc>
-                <a:spcPct val="100000"/>
-              </a:lnSpc>
-              <a:spcBef>
-                <a:spcPts val="0"/>
-              </a:spcBef>
-              <a:spcAft>
-                <a:spcPts val="200"/>
-              </a:spcAft>
-            </a:pPr>
-            <a:r>
-              <a:rPr sz="1150" b="0" i="0">
-                <a:solidFill>
-                  <a:srgbClr val="B8B8C6"/>
-                </a:solidFill>
-                <a:latin typeface="Segoe UI"/>
-              </a:rPr>
-              <a:t>Resumable pipeline / state machine</a:t>
-            </a:r>
-          </a:p>
-        </p:txBody>
-      </p:sp>
-      <p:sp>
-        <p:nvSpPr>
-          <p:cNvPr id="29" name="Oval 28"/>
-          <p:cNvSpPr/>
-          <p:nvPr/>
-        </p:nvSpPr>
-        <p:spPr>
-          <a:xfrm>
-            <a:off x="4572000" y="4032504"/>
-            <a:ext cx="128016" cy="128016"/>
-          </a:xfrm>
-          <a:prstGeom prst="ellipse">
-            <a:avLst/>
-          </a:prstGeom>
-          <a:solidFill>
-            <a:srgbClr val="FFE600"/>
-          </a:solidFill>
-          <a:ln>
-            <a:noFill/>
-          </a:ln>
-          <a:effectLst/>
-        </p:spPr>
-        <p:style>
-          <a:lnRef idx="1">
-            <a:schemeClr val="accent1"/>
-          </a:lnRef>
-          <a:fillRef idx="3">
-            <a:schemeClr val="accent1"/>
-          </a:fillRef>
-          <a:effectRef idx="2">
-            <a:schemeClr val="accent1"/>
-          </a:effectRef>
-          <a:fontRef idx="minor">
-            <a:schemeClr val="lt1"/>
-          </a:fontRef>
-        </p:style>
-        <p:txBody>
-          <a:bodyPr rtlCol="0" anchor="ctr"/>
-          <a:lstStyle/>
-          <a:p>
-            <a:pPr algn="ctr"/>
-          </a:p>
-        </p:txBody>
-      </p:sp>
-      <p:sp>
-        <p:nvSpPr>
-          <p:cNvPr id="30" name="TextBox 29"/>
-          <p:cNvSpPr txBox="1"/>
-          <p:nvPr/>
-        </p:nvSpPr>
-        <p:spPr>
-          <a:xfrm>
-            <a:off x="4828031" y="3986784"/>
-            <a:ext cx="2834640" cy="548640"/>
-          </a:xfrm>
-          <a:prstGeom prst="rect">
-            <a:avLst/>
-          </a:prstGeom>
-          <a:noFill/>
-        </p:spPr>
-        <p:txBody>
-          <a:bodyPr wrap="square" anchor="t" lIns="0" rIns="0" tIns="0" bIns="0">
-            <a:spAutoFit/>
-          </a:bodyPr>
-          <a:lstStyle/>
-          <a:p>
-            <a:pPr algn="l">
-              <a:lnSpc>
-                <a:spcPct val="100000"/>
-              </a:lnSpc>
-              <a:spcBef>
-                <a:spcPts val="0"/>
-              </a:spcBef>
-              <a:spcAft>
-                <a:spcPts val="200"/>
-              </a:spcAft>
-            </a:pPr>
-            <a:r>
-              <a:rPr sz="1150" b="0" i="0">
-                <a:solidFill>
-                  <a:srgbClr val="B8B8C6"/>
-                </a:solidFill>
-                <a:latin typeface="Segoe UI"/>
-              </a:rPr>
-              <a:t>Data-driven, not hard-coded rules</a:t>
-            </a:r>
-          </a:p>
-        </p:txBody>
-      </p:sp>
-      <p:sp>
-        <p:nvSpPr>
-          <p:cNvPr id="31" name="Oval 30"/>
-          <p:cNvSpPr/>
-          <p:nvPr/>
-        </p:nvSpPr>
-        <p:spPr>
-          <a:xfrm>
-            <a:off x="4572000" y="4654296"/>
-            <a:ext cx="128016" cy="128016"/>
-          </a:xfrm>
-          <a:prstGeom prst="ellipse">
-            <a:avLst/>
-          </a:prstGeom>
-          <a:solidFill>
-            <a:srgbClr val="FFE600"/>
-          </a:solidFill>
-          <a:ln>
-            <a:noFill/>
-          </a:ln>
-          <a:effectLst/>
-        </p:spPr>
-        <p:style>
-          <a:lnRef idx="1">
-            <a:schemeClr val="accent1"/>
-          </a:lnRef>
-          <a:fillRef idx="3">
-            <a:schemeClr val="accent1"/>
-          </a:fillRef>
-          <a:effectRef idx="2">
-            <a:schemeClr val="accent1"/>
-          </a:effectRef>
-          <a:fontRef idx="minor">
-            <a:schemeClr val="lt1"/>
-          </a:fontRef>
-        </p:style>
-        <p:txBody>
-          <a:bodyPr rtlCol="0" anchor="ctr"/>
-          <a:lstStyle/>
-          <a:p>
-            <a:pPr algn="ctr"/>
-          </a:p>
-        </p:txBody>
-      </p:sp>
-      <p:sp>
-        <p:nvSpPr>
-          <p:cNvPr id="32" name="TextBox 31"/>
-          <p:cNvSpPr txBox="1"/>
-          <p:nvPr/>
-        </p:nvSpPr>
-        <p:spPr>
-          <a:xfrm>
-            <a:off x="4828031" y="4608576"/>
-            <a:ext cx="2834640" cy="548640"/>
-          </a:xfrm>
-          <a:prstGeom prst="rect">
-            <a:avLst/>
-          </a:prstGeom>
-          <a:noFill/>
-        </p:spPr>
-        <p:txBody>
-          <a:bodyPr wrap="square" anchor="t" lIns="0" rIns="0" tIns="0" bIns="0">
-            <a:spAutoFit/>
-          </a:bodyPr>
-          <a:lstStyle/>
-          <a:p>
-            <a:pPr algn="l">
-              <a:lnSpc>
-                <a:spcPct val="100000"/>
-              </a:lnSpc>
-              <a:spcBef>
-                <a:spcPts val="0"/>
-              </a:spcBef>
-              <a:spcAft>
-                <a:spcPts val="200"/>
-              </a:spcAft>
-            </a:pPr>
-            <a:r>
-              <a:rPr sz="1150" b="0" i="0">
-                <a:solidFill>
-                  <a:srgbClr val="B8B8C6"/>
-                </a:solidFill>
-                <a:latin typeface="Segoe UI"/>
-              </a:rPr>
-              <a:t>Human-in-the-loop by design</a:t>
-            </a:r>
-          </a:p>
-        </p:txBody>
-      </p:sp>
-      <p:sp>
-        <p:nvSpPr>
-          <p:cNvPr id="33" name="Oval 32"/>
-          <p:cNvSpPr/>
-          <p:nvPr/>
-        </p:nvSpPr>
-        <p:spPr>
-          <a:xfrm>
-            <a:off x="4572000" y="5276088"/>
-            <a:ext cx="128016" cy="128016"/>
-          </a:xfrm>
-          <a:prstGeom prst="ellipse">
-            <a:avLst/>
-          </a:prstGeom>
-          <a:solidFill>
-            <a:srgbClr val="FFE600"/>
-          </a:solidFill>
-          <a:ln>
-            <a:noFill/>
-          </a:ln>
-          <a:effectLst/>
-        </p:spPr>
-        <p:style>
-          <a:lnRef idx="1">
-            <a:schemeClr val="accent1"/>
-          </a:lnRef>
-          <a:fillRef idx="3">
-            <a:schemeClr val="accent1"/>
-          </a:fillRef>
-          <a:effectRef idx="2">
-            <a:schemeClr val="accent1"/>
-          </a:effectRef>
-          <a:fontRef idx="minor">
-            <a:schemeClr val="lt1"/>
-          </a:fontRef>
-        </p:style>
-        <p:txBody>
-          <a:bodyPr rtlCol="0" anchor="ctr"/>
-          <a:lstStyle/>
-          <a:p>
-            <a:pPr algn="ctr"/>
-          </a:p>
-        </p:txBody>
-      </p:sp>
-      <p:sp>
-        <p:nvSpPr>
-          <p:cNvPr id="34" name="TextBox 33"/>
-          <p:cNvSpPr txBox="1"/>
-          <p:nvPr/>
-        </p:nvSpPr>
-        <p:spPr>
-          <a:xfrm>
-            <a:off x="4828031" y="5230368"/>
-            <a:ext cx="2834640" cy="548640"/>
-          </a:xfrm>
-          <a:prstGeom prst="rect">
-            <a:avLst/>
-          </a:prstGeom>
-          <a:noFill/>
-        </p:spPr>
-        <p:txBody>
-          <a:bodyPr wrap="square" anchor="t" lIns="0" rIns="0" tIns="0" bIns="0">
-            <a:spAutoFit/>
-          </a:bodyPr>
-          <a:lstStyle/>
-          <a:p>
-            <a:pPr algn="l">
-              <a:lnSpc>
-                <a:spcPct val="100000"/>
-              </a:lnSpc>
-              <a:spcBef>
-                <a:spcPts val="0"/>
-              </a:spcBef>
-              <a:spcAft>
-                <a:spcPts val="200"/>
-              </a:spcAft>
-            </a:pPr>
-            <a:r>
-              <a:rPr sz="1150" b="0" i="0">
-                <a:solidFill>
-                  <a:srgbClr val="B8B8C6"/>
-                </a:solidFill>
-                <a:latin typeface="Segoe UI"/>
-              </a:rPr>
-              <a:t>Audit-first for governance</a:t>
-            </a:r>
-          </a:p>
-        </p:txBody>
-      </p:sp>
-      <p:sp>
-        <p:nvSpPr>
-          <p:cNvPr id="35" name="Rounded Rectangle 34"/>
-          <p:cNvSpPr/>
-          <p:nvPr/>
-        </p:nvSpPr>
-        <p:spPr>
-          <a:xfrm>
-            <a:off x="8010144" y="1783080"/>
-            <a:ext cx="3611880" cy="4114800"/>
-          </a:xfrm>
-          <a:prstGeom prst="roundRect">
-            <a:avLst>
-              <a:gd name="adj" fmla="val 8000"/>
-            </a:avLst>
-          </a:prstGeom>
-          <a:solidFill>
-            <a:srgbClr val="242433"/>
-          </a:solidFill>
-          <a:ln>
-            <a:noFill/>
-          </a:ln>
-          <a:effectLst/>
-        </p:spPr>
-        <p:style>
-          <a:lnRef idx="1">
-            <a:schemeClr val="accent1"/>
-          </a:lnRef>
-          <a:fillRef idx="3">
-            <a:schemeClr val="accent1"/>
-          </a:fillRef>
-          <a:effectRef idx="2">
-            <a:schemeClr val="accent1"/>
-          </a:effectRef>
-          <a:fontRef idx="minor">
-            <a:schemeClr val="lt1"/>
-          </a:fontRef>
-        </p:style>
-        <p:txBody>
-          <a:bodyPr rtlCol="0" anchor="ctr" wrap="square"/>
-          <a:lstStyle/>
-          <a:p>
-            <a:pPr algn="ctr"/>
-          </a:p>
-        </p:txBody>
-      </p:sp>
-      <p:sp>
-        <p:nvSpPr>
-          <p:cNvPr id="36" name="Rectangle 35"/>
-          <p:cNvSpPr/>
-          <p:nvPr/>
-        </p:nvSpPr>
-        <p:spPr>
-          <a:xfrm>
-            <a:off x="8010144" y="1783080"/>
-            <a:ext cx="3611880" cy="109728"/>
-          </a:xfrm>
-          <a:prstGeom prst="rect">
-            <a:avLst/>
-          </a:prstGeom>
-          <a:solidFill>
-            <a:srgbClr val="4A9EFF"/>
-          </a:solidFill>
-          <a:ln>
-            <a:noFill/>
-          </a:ln>
-          <a:effectLst/>
-        </p:spPr>
-        <p:style>
-          <a:lnRef idx="1">
-            <a:schemeClr val="accent1"/>
-          </a:lnRef>
-          <a:fillRef idx="3">
-            <a:schemeClr val="accent1"/>
-          </a:fillRef>
-          <a:effectRef idx="2">
-            <a:schemeClr val="accent1"/>
-          </a:effectRef>
-          <a:fontRef idx="minor">
-            <a:schemeClr val="lt1"/>
-          </a:fontRef>
-        </p:style>
-        <p:txBody>
-          <a:bodyPr rtlCol="0" anchor="ctr" wrap="square"/>
-          <a:lstStyle/>
-          <a:p>
-            <a:pPr algn="ctr"/>
-          </a:p>
-        </p:txBody>
-      </p:sp>
-      <p:sp>
-        <p:nvSpPr>
-          <p:cNvPr id="37" name="TextBox 36"/>
-          <p:cNvSpPr txBox="1"/>
-          <p:nvPr/>
-        </p:nvSpPr>
-        <p:spPr>
-          <a:xfrm>
-            <a:off x="8284464" y="2103120"/>
-            <a:ext cx="3108960" cy="457200"/>
-          </a:xfrm>
-          <a:prstGeom prst="rect">
-            <a:avLst/>
-          </a:prstGeom>
-          <a:noFill/>
-        </p:spPr>
-        <p:txBody>
-          <a:bodyPr wrap="square" anchor="t" lIns="0" rIns="0" tIns="0" bIns="0">
-            <a:spAutoFit/>
-          </a:bodyPr>
-          <a:lstStyle/>
-          <a:p>
-            <a:pPr algn="l">
-              <a:lnSpc>
-                <a:spcPct val="100000"/>
-              </a:lnSpc>
-              <a:spcBef>
-                <a:spcPts val="0"/>
-              </a:spcBef>
-              <a:spcAft>
-                <a:spcPts val="200"/>
-              </a:spcAft>
-            </a:pPr>
-            <a:r>
-              <a:rPr sz="1500" b="1" i="0">
-                <a:solidFill>
-                  <a:srgbClr val="FFFFFF"/>
-                </a:solidFill>
-                <a:latin typeface="Segoe UI"/>
-              </a:rPr>
-              <a:t>Enterprise readiness</a:t>
-            </a:r>
-          </a:p>
-        </p:txBody>
-      </p:sp>
-      <p:sp>
-        <p:nvSpPr>
-          <p:cNvPr id="38" name="Oval 37"/>
-          <p:cNvSpPr/>
-          <p:nvPr/>
-        </p:nvSpPr>
-        <p:spPr>
-          <a:xfrm>
-            <a:off x="8302752" y="2788920"/>
-            <a:ext cx="128016" cy="128016"/>
-          </a:xfrm>
-          <a:prstGeom prst="ellipse">
-            <a:avLst/>
-          </a:prstGeom>
-          <a:solidFill>
-            <a:srgbClr val="4A9EFF"/>
-          </a:solidFill>
-          <a:ln>
-            <a:noFill/>
-          </a:ln>
-          <a:effectLst/>
-        </p:spPr>
-        <p:style>
-          <a:lnRef idx="1">
-            <a:schemeClr val="accent1"/>
-          </a:lnRef>
-          <a:fillRef idx="3">
-            <a:schemeClr val="accent1"/>
-          </a:fillRef>
-          <a:effectRef idx="2">
-            <a:schemeClr val="accent1"/>
-          </a:effectRef>
-          <a:fontRef idx="minor">
-            <a:schemeClr val="lt1"/>
-          </a:fontRef>
-        </p:style>
-        <p:txBody>
-          <a:bodyPr rtlCol="0" anchor="ctr"/>
-          <a:lstStyle/>
-          <a:p>
-            <a:pPr algn="ctr"/>
-          </a:p>
-        </p:txBody>
-      </p:sp>
-      <p:sp>
-        <p:nvSpPr>
-          <p:cNvPr id="39" name="TextBox 38"/>
-          <p:cNvSpPr txBox="1"/>
-          <p:nvPr/>
-        </p:nvSpPr>
-        <p:spPr>
-          <a:xfrm>
-            <a:off x="8558784" y="2743200"/>
-            <a:ext cx="2834640" cy="548640"/>
-          </a:xfrm>
-          <a:prstGeom prst="rect">
-            <a:avLst/>
-          </a:prstGeom>
-          <a:noFill/>
-        </p:spPr>
-        <p:txBody>
-          <a:bodyPr wrap="square" anchor="t" lIns="0" rIns="0" tIns="0" bIns="0">
-            <a:spAutoFit/>
-          </a:bodyPr>
-          <a:lstStyle/>
-          <a:p>
-            <a:pPr algn="l">
-              <a:lnSpc>
-                <a:spcPct val="100000"/>
-              </a:lnSpc>
-              <a:spcBef>
-                <a:spcPts val="0"/>
-              </a:spcBef>
-              <a:spcAft>
-                <a:spcPts val="200"/>
-              </a:spcAft>
-            </a:pPr>
-            <a:r>
-              <a:rPr sz="1150" b="0" i="0">
-                <a:solidFill>
-                  <a:srgbClr val="B8B8C6"/>
-                </a:solidFill>
-                <a:latin typeface="Segoe UI"/>
-              </a:rPr>
-              <a:t>Integrates with ERP / MDM / pricing</a:t>
-            </a:r>
-          </a:p>
-        </p:txBody>
-      </p:sp>
-      <p:sp>
-        <p:nvSpPr>
-          <p:cNvPr id="40" name="Oval 39"/>
-          <p:cNvSpPr/>
-          <p:nvPr/>
-        </p:nvSpPr>
-        <p:spPr>
-          <a:xfrm>
-            <a:off x="8302752" y="3410712"/>
-            <a:ext cx="128016" cy="128016"/>
-          </a:xfrm>
-          <a:prstGeom prst="ellipse">
-            <a:avLst/>
-          </a:prstGeom>
-          <a:solidFill>
-            <a:srgbClr val="4A9EFF"/>
-          </a:solidFill>
-          <a:ln>
-            <a:noFill/>
-          </a:ln>
-          <a:effectLst/>
-        </p:spPr>
-        <p:style>
-          <a:lnRef idx="1">
-            <a:schemeClr val="accent1"/>
-          </a:lnRef>
-          <a:fillRef idx="3">
-            <a:schemeClr val="accent1"/>
-          </a:fillRef>
-          <a:effectRef idx="2">
-            <a:schemeClr val="accent1"/>
-          </a:effectRef>
-          <a:fontRef idx="minor">
-            <a:schemeClr val="lt1"/>
-          </a:fontRef>
-        </p:style>
-        <p:txBody>
-          <a:bodyPr rtlCol="0" anchor="ctr"/>
-          <a:lstStyle/>
-          <a:p>
-            <a:pPr algn="ctr"/>
-          </a:p>
-        </p:txBody>
-      </p:sp>
-      <p:sp>
-        <p:nvSpPr>
-          <p:cNvPr id="41" name="TextBox 40"/>
-          <p:cNvSpPr txBox="1"/>
-          <p:nvPr/>
-        </p:nvSpPr>
-        <p:spPr>
-          <a:xfrm>
-            <a:off x="8558784" y="3364992"/>
-            <a:ext cx="2834640" cy="548640"/>
-          </a:xfrm>
-          <a:prstGeom prst="rect">
-            <a:avLst/>
-          </a:prstGeom>
-          <a:noFill/>
-        </p:spPr>
-        <p:txBody>
-          <a:bodyPr wrap="square" anchor="t" lIns="0" rIns="0" tIns="0" bIns="0">
-            <a:spAutoFit/>
-          </a:bodyPr>
-          <a:lstStyle/>
-          <a:p>
-            <a:pPr algn="l">
-              <a:lnSpc>
-                <a:spcPct val="100000"/>
-              </a:lnSpc>
-              <a:spcBef>
-                <a:spcPts val="0"/>
-              </a:spcBef>
-              <a:spcAft>
-                <a:spcPts val="200"/>
-              </a:spcAft>
-            </a:pPr>
-            <a:r>
-              <a:rPr sz="1150" b="0" i="0">
-                <a:solidFill>
-                  <a:srgbClr val="B8B8C6"/>
-                </a:solidFill>
-                <a:latin typeface="Segoe UI"/>
-              </a:rPr>
-              <a:t>Live master-data connectivity</a:t>
-            </a:r>
-          </a:p>
-        </p:txBody>
-      </p:sp>
-      <p:sp>
-        <p:nvSpPr>
-          <p:cNvPr id="42" name="Oval 41"/>
-          <p:cNvSpPr/>
-          <p:nvPr/>
-        </p:nvSpPr>
-        <p:spPr>
-          <a:xfrm>
-            <a:off x="8302752" y="4032504"/>
-            <a:ext cx="128016" cy="128016"/>
-          </a:xfrm>
-          <a:prstGeom prst="ellipse">
-            <a:avLst/>
-          </a:prstGeom>
-          <a:solidFill>
-            <a:srgbClr val="4A9EFF"/>
-          </a:solidFill>
-          <a:ln>
-            <a:noFill/>
-          </a:ln>
-          <a:effectLst/>
-        </p:spPr>
-        <p:style>
-          <a:lnRef idx="1">
-            <a:schemeClr val="accent1"/>
-          </a:lnRef>
-          <a:fillRef idx="3">
-            <a:schemeClr val="accent1"/>
-          </a:fillRef>
-          <a:effectRef idx="2">
-            <a:schemeClr val="accent1"/>
-          </a:effectRef>
-          <a:fontRef idx="minor">
-            <a:schemeClr val="lt1"/>
-          </a:fontRef>
-        </p:style>
-        <p:txBody>
-          <a:bodyPr rtlCol="0" anchor="ctr"/>
-          <a:lstStyle/>
-          <a:p>
-            <a:pPr algn="ctr"/>
-          </a:p>
-        </p:txBody>
-      </p:sp>
-      <p:sp>
-        <p:nvSpPr>
-          <p:cNvPr id="43" name="TextBox 42"/>
-          <p:cNvSpPr txBox="1"/>
-          <p:nvPr/>
-        </p:nvSpPr>
-        <p:spPr>
-          <a:xfrm>
-            <a:off x="8558784" y="3986784"/>
-            <a:ext cx="2834640" cy="548640"/>
-          </a:xfrm>
-          <a:prstGeom prst="rect">
-            <a:avLst/>
-          </a:prstGeom>
-          <a:noFill/>
-        </p:spPr>
-        <p:txBody>
-          <a:bodyPr wrap="square" anchor="t" lIns="0" rIns="0" tIns="0" bIns="0">
-            <a:spAutoFit/>
-          </a:bodyPr>
-          <a:lstStyle/>
-          <a:p>
-            <a:pPr algn="l">
-              <a:lnSpc>
-                <a:spcPct val="100000"/>
-              </a:lnSpc>
-              <a:spcBef>
-                <a:spcPts val="0"/>
-              </a:spcBef>
-              <a:spcAft>
-                <a:spcPts val="200"/>
-              </a:spcAft>
-            </a:pPr>
-            <a:r>
-              <a:rPr sz="1150" b="0" i="0">
-                <a:solidFill>
-                  <a:srgbClr val="B8B8C6"/>
-                </a:solidFill>
-                <a:latin typeface="Segoe UI"/>
-              </a:rPr>
-              <a:t>LLM-assisted extraction &amp; reasoning</a:t>
-            </a:r>
-          </a:p>
-        </p:txBody>
-      </p:sp>
-      <p:sp>
-        <p:nvSpPr>
-          <p:cNvPr id="44" name="Oval 43"/>
-          <p:cNvSpPr/>
-          <p:nvPr/>
-        </p:nvSpPr>
-        <p:spPr>
-          <a:xfrm>
-            <a:off x="8302752" y="4654296"/>
-            <a:ext cx="128016" cy="128016"/>
-          </a:xfrm>
-          <a:prstGeom prst="ellipse">
-            <a:avLst/>
-          </a:prstGeom>
-          <a:solidFill>
-            <a:srgbClr val="4A9EFF"/>
-          </a:solidFill>
-          <a:ln>
-            <a:noFill/>
-          </a:ln>
-          <a:effectLst/>
-        </p:spPr>
-        <p:style>
-          <a:lnRef idx="1">
-            <a:schemeClr val="accent1"/>
-          </a:lnRef>
-          <a:fillRef idx="3">
-            <a:schemeClr val="accent1"/>
-          </a:fillRef>
-          <a:effectRef idx="2">
-            <a:schemeClr val="accent1"/>
-          </a:effectRef>
-          <a:fontRef idx="minor">
-            <a:schemeClr val="lt1"/>
-          </a:fontRef>
-        </p:style>
-        <p:txBody>
-          <a:bodyPr rtlCol="0" anchor="ctr"/>
-          <a:lstStyle/>
-          <a:p>
-            <a:pPr algn="ctr"/>
-          </a:p>
-        </p:txBody>
-      </p:sp>
-      <p:sp>
-        <p:nvSpPr>
-          <p:cNvPr id="45" name="TextBox 44"/>
-          <p:cNvSpPr txBox="1"/>
-          <p:nvPr/>
-        </p:nvSpPr>
-        <p:spPr>
-          <a:xfrm>
-            <a:off x="8558784" y="4608576"/>
-            <a:ext cx="2834640" cy="548640"/>
-          </a:xfrm>
-          <a:prstGeom prst="rect">
-            <a:avLst/>
-          </a:prstGeom>
-          <a:noFill/>
-        </p:spPr>
-        <p:txBody>
-          <a:bodyPr wrap="square" anchor="t" lIns="0" rIns="0" tIns="0" bIns="0">
-            <a:spAutoFit/>
-          </a:bodyPr>
-          <a:lstStyle/>
-          <a:p>
-            <a:pPr algn="l">
-              <a:lnSpc>
-                <a:spcPct val="100000"/>
-              </a:lnSpc>
-              <a:spcBef>
-                <a:spcPts val="0"/>
-              </a:spcBef>
-              <a:spcAft>
-                <a:spcPts val="200"/>
-              </a:spcAft>
-            </a:pPr>
-            <a:r>
-              <a:rPr sz="1150" b="0" i="0">
-                <a:solidFill>
-                  <a:srgbClr val="B8B8C6"/>
-                </a:solidFill>
-                <a:latin typeface="Segoe UI"/>
-              </a:rPr>
-              <a:t>Enterprise auth, roles &amp; SLAs</a:t>
-            </a:r>
-          </a:p>
-        </p:txBody>
-      </p:sp>
-      <p:sp>
-        <p:nvSpPr>
-          <p:cNvPr id="46" name="Oval 45"/>
-          <p:cNvSpPr/>
-          <p:nvPr/>
-        </p:nvSpPr>
-        <p:spPr>
-          <a:xfrm>
-            <a:off x="8302752" y="5276088"/>
-            <a:ext cx="128016" cy="128016"/>
-          </a:xfrm>
-          <a:prstGeom prst="ellipse">
-            <a:avLst/>
-          </a:prstGeom>
-          <a:solidFill>
-            <a:srgbClr val="4A9EFF"/>
-          </a:solidFill>
-          <a:ln>
-            <a:noFill/>
-          </a:ln>
-          <a:effectLst/>
-        </p:spPr>
-        <p:style>
-          <a:lnRef idx="1">
-            <a:schemeClr val="accent1"/>
-          </a:lnRef>
-          <a:fillRef idx="3">
-            <a:schemeClr val="accent1"/>
-          </a:fillRef>
-          <a:effectRef idx="2">
-            <a:schemeClr val="accent1"/>
-          </a:effectRef>
-          <a:fontRef idx="minor">
-            <a:schemeClr val="lt1"/>
-          </a:fontRef>
-        </p:style>
-        <p:txBody>
-          <a:bodyPr rtlCol="0" anchor="ctr"/>
-          <a:lstStyle/>
-          <a:p>
-            <a:pPr algn="ctr"/>
-          </a:p>
-        </p:txBody>
-      </p:sp>
-      <p:sp>
-        <p:nvSpPr>
-          <p:cNvPr id="47" name="TextBox 46"/>
-          <p:cNvSpPr txBox="1"/>
-          <p:nvPr/>
-        </p:nvSpPr>
-        <p:spPr>
-          <a:xfrm>
-            <a:off x="8558784" y="5230368"/>
-            <a:ext cx="2834640" cy="548640"/>
-          </a:xfrm>
-          <a:prstGeom prst="rect">
-            <a:avLst/>
-          </a:prstGeom>
-          <a:noFill/>
-        </p:spPr>
-        <p:txBody>
-          <a:bodyPr wrap="square" anchor="t" lIns="0" rIns="0" tIns="0" bIns="0">
-            <a:spAutoFit/>
-          </a:bodyPr>
-          <a:lstStyle/>
-          <a:p>
-            <a:pPr algn="l">
-              <a:lnSpc>
-                <a:spcPct val="100000"/>
-              </a:lnSpc>
-              <a:spcBef>
-                <a:spcPts val="0"/>
-              </a:spcBef>
-              <a:spcAft>
-                <a:spcPts val="200"/>
-              </a:spcAft>
-            </a:pPr>
-            <a:r>
-              <a:rPr sz="1150" b="0" i="0">
-                <a:solidFill>
-                  <a:srgbClr val="B8B8C6"/>
-                </a:solidFill>
-                <a:latin typeface="Segoe UI"/>
-              </a:rPr>
-              <a:t>Cloud deployment &amp; monitoring</a:t>
-            </a:r>
-          </a:p>
-        </p:txBody>
-      </p:sp>
-    </p:spTree>
-  </p:cSld>
-  <p:clrMapOvr>
-    <a:masterClrMapping/>
-  </p:clrMapOvr>
-</p:sld>
-</file>
-
-<file path=ppt/slides/slide21.xml><?xml version="1.0" encoding="utf-8"?>
 <p:sld xmlns:a="http://schemas.openxmlformats.org/drawingml/2006/main" xmlns:p="http://schemas.openxmlformats.org/presentationml/2006/main" xmlns:r="http://schemas.openxmlformats.org/officeDocument/2006/relationships">
   <p:cSld>
     <p:spTree>

</xml_diff>